<commit_message>
Update KPI business metrics template and associated assets
Replit-Commit-Author: Agent
</commit_message>
<xml_diff>
--- a/attached_assets/kpi_business_metrics_four_entity_template.pptx
+++ b/attached_assets/kpi_business_metrics_four_entity_template.pptx
@@ -2305,7 +2305,7 @@
                 <a:ea typeface="Arial" pitchFamily="34" charset="-122"/>
                 <a:cs typeface="Arial" pitchFamily="34" charset="-120"/>
               </a:rPr>
-              <a:t>Green: governed scope  •  Red: Phase 2 / out of scope</a:t>
+              <a:t>Governed green scope</a:t>
             </a:r>
             <a:endParaRPr lang="en-US" sz="700" dirty="0"/>
           </a:p>
@@ -2320,7 +2320,7 @@
         <p:spPr>
           <a:xfrm>
             <a:off x="429768" y="1938528"/>
-            <a:ext cx="68580" cy="772668"/>
+            <a:ext cx="68580" cy="992124"/>
           </a:xfrm>
           <a:prstGeom prst="rect">
             <a:avLst/>
@@ -2388,7 +2388,7 @@
         <p:spPr>
           <a:xfrm>
             <a:off x="749808" y="2139696"/>
-            <a:ext cx="10716768" cy="594360"/>
+            <a:ext cx="10716768" cy="813816"/>
           </a:xfrm>
           <a:prstGeom prst="rect">
             <a:avLst/>
@@ -2445,8 +2445,8 @@
         </p:nvSpPr>
         <p:spPr>
           <a:xfrm>
-            <a:off x="429768" y="2743200"/>
-            <a:ext cx="68580" cy="662940"/>
+            <a:off x="429768" y="2990088"/>
+            <a:ext cx="68580" cy="937260"/>
           </a:xfrm>
           <a:prstGeom prst="rect">
             <a:avLst/>
@@ -2472,7 +2472,7 @@
         </p:nvSpPr>
         <p:spPr>
           <a:xfrm>
-            <a:off x="612648" y="2761488"/>
+            <a:off x="612648" y="3008376"/>
             <a:ext cx="3657600" cy="155448"/>
           </a:xfrm>
           <a:prstGeom prst="rect">
@@ -2513,8 +2513,8 @@
         </p:nvSpPr>
         <p:spPr>
           <a:xfrm>
-            <a:off x="749808" y="2944368"/>
-            <a:ext cx="10716768" cy="484632"/>
+            <a:off x="749808" y="3191256"/>
+            <a:ext cx="10716768" cy="758952"/>
           </a:xfrm>
           <a:prstGeom prst="rect">
             <a:avLst/>
@@ -2571,8 +2571,8 @@
         </p:nvSpPr>
         <p:spPr>
           <a:xfrm>
-            <a:off x="429768" y="3438144"/>
-            <a:ext cx="68580" cy="662940"/>
+            <a:off x="429768" y="4005072"/>
+            <a:ext cx="68580" cy="937260"/>
           </a:xfrm>
           <a:prstGeom prst="rect">
             <a:avLst/>
@@ -2598,7 +2598,7 @@
         </p:nvSpPr>
         <p:spPr>
           <a:xfrm>
-            <a:off x="612648" y="3456432"/>
+            <a:off x="612648" y="4023360"/>
             <a:ext cx="3657600" cy="155448"/>
           </a:xfrm>
           <a:prstGeom prst="rect">
@@ -2639,8 +2639,8 @@
         </p:nvSpPr>
         <p:spPr>
           <a:xfrm>
-            <a:off x="749808" y="3639312"/>
-            <a:ext cx="10716768" cy="484632"/>
+            <a:off x="749808" y="4206240"/>
+            <a:ext cx="10716768" cy="758952"/>
           </a:xfrm>
           <a:prstGeom prst="rect">
             <a:avLst/>
@@ -2697,8 +2697,8 @@
         </p:nvSpPr>
         <p:spPr>
           <a:xfrm>
-            <a:off x="429768" y="4133088"/>
-            <a:ext cx="68580" cy="662940"/>
+            <a:off x="429768" y="5020056"/>
+            <a:ext cx="68580" cy="937260"/>
           </a:xfrm>
           <a:prstGeom prst="rect">
             <a:avLst/>
@@ -2724,7 +2724,7 @@
         </p:nvSpPr>
         <p:spPr>
           <a:xfrm>
-            <a:off x="612648" y="4151376"/>
+            <a:off x="612648" y="5038344"/>
             <a:ext cx="3657600" cy="155448"/>
           </a:xfrm>
           <a:prstGeom prst="rect">
@@ -2765,8 +2765,8 @@
         </p:nvSpPr>
         <p:spPr>
           <a:xfrm>
-            <a:off x="749808" y="4334256"/>
-            <a:ext cx="10716768" cy="484632"/>
+            <a:off x="749808" y="5221224"/>
+            <a:ext cx="10716768" cy="758952"/>
           </a:xfrm>
           <a:prstGeom prst="rect">
             <a:avLst/>
@@ -2823,8 +2823,222 @@
         </p:nvSpPr>
         <p:spPr>
           <a:xfrm>
-            <a:off x="429768" y="4828032"/>
-            <a:ext cx="68580" cy="553212"/>
+            <a:off x="438912" y="6144768"/>
+            <a:ext cx="11283696" cy="0"/>
+          </a:xfrm>
+          <a:prstGeom prst="line">
+            <a:avLst/>
+          </a:prstGeom>
+          <a:noFill/>
+          <a:ln w="12700">
+            <a:solidFill>
+              <a:srgbClr val="AFAFAF"/>
+            </a:solidFill>
+            <a:prstDash val="solid"/>
+          </a:ln>
+        </p:spPr>
+      </p:sp>
+      <p:sp>
+        <p:nvSpPr>
+          <p:cNvPr id="51" name="Text 49"/>
+          <p:cNvSpPr/>
+          <p:nvPr/>
+        </p:nvSpPr>
+        <p:spPr>
+          <a:xfrm>
+            <a:off x="438912" y="6254496"/>
+            <a:ext cx="1828800" cy="155448"/>
+          </a:xfrm>
+          <a:prstGeom prst="rect">
+            <a:avLst/>
+          </a:prstGeom>
+          <a:noFill/>
+          <a:ln/>
+        </p:spPr>
+        <p:txBody>
+          <a:bodyPr wrap="square" lIns="0" tIns="0" rIns="0" bIns="0" rtlCol="0" anchor="t">
+            <a:normAutofit/>
+          </a:bodyPr>
+          <a:lstStyle/>
+          <a:p>
+            <a:pPr indent="0" marL="0">
+              <a:buNone/>
+            </a:pPr>
+            <a:r>
+              <a:rPr lang="en-US" sz="840" b="1" dirty="0">
+                <a:solidFill>
+                  <a:srgbClr val="8C2465"/>
+                </a:solidFill>
+                <a:latin typeface="Arial" pitchFamily="34" charset="0"/>
+                <a:ea typeface="Arial" pitchFamily="34" charset="-122"/>
+                <a:cs typeface="Arial" pitchFamily="34" charset="-120"/>
+              </a:rPr>
+              <a:t>Source &amp; governance</a:t>
+            </a:r>
+            <a:endParaRPr lang="en-US" sz="840" dirty="0"/>
+          </a:p>
+        </p:txBody>
+      </p:sp>
+      <p:sp>
+        <p:nvSpPr>
+          <p:cNvPr id="52" name="Text 50"/>
+          <p:cNvSpPr/>
+          <p:nvPr/>
+        </p:nvSpPr>
+        <p:spPr>
+          <a:xfrm>
+            <a:off x="438912" y="6464808"/>
+            <a:ext cx="11228832" cy="274320"/>
+          </a:xfrm>
+          <a:prstGeom prst="rect">
+            <a:avLst/>
+          </a:prstGeom>
+          <a:noFill/>
+          <a:ln/>
+        </p:spPr>
+        <p:txBody>
+          <a:bodyPr wrap="square" lIns="0" tIns="0" rIns="0" bIns="0" rtlCol="0" anchor="t">
+            <a:normAutofit/>
+          </a:bodyPr>
+          <a:lstStyle/>
+          <a:p>
+            <a:pPr indent="0" marL="0">
+              <a:buNone/>
+            </a:pPr>
+            <a:r>
+              <a:rPr lang="en-US" sz="670" dirty="0">
+                <a:solidFill>
+                  <a:srgbClr val="626262"/>
+                </a:solidFill>
+                <a:latin typeface="Arial" pitchFamily="34" charset="0"/>
+                <a:ea typeface="Arial" pitchFamily="34" charset="-122"/>
+                <a:cs typeface="Arial" pitchFamily="34" charset="-120"/>
+              </a:rPr>
+              <a:t>{{ww_source_note}}  •  Actuals: {{ww_actual_source_label}}  •  Forecast: {{ww_forecast_source_label}}  •  {{ww_period_label}}</a:t>
+            </a:r>
+            <a:endParaRPr lang="en-US" sz="670" dirty="0"/>
+          </a:p>
+        </p:txBody>
+      </p:sp>
+      <p:sp>
+        <p:nvSpPr>
+          <p:cNvPr id="53" name="Text 51"/>
+          <p:cNvSpPr/>
+          <p:nvPr/>
+        </p:nvSpPr>
+        <p:spPr>
+          <a:xfrm>
+            <a:off x="438912" y="6784848"/>
+            <a:ext cx="11228832" cy="219456"/>
+          </a:xfrm>
+          <a:prstGeom prst="rect">
+            <a:avLst/>
+          </a:prstGeom>
+          <a:noFill/>
+          <a:ln/>
+        </p:spPr>
+        <p:txBody>
+          <a:bodyPr wrap="square" lIns="0" tIns="0" rIns="0" bIns="0" rtlCol="0" anchor="t">
+            <a:normAutofit/>
+          </a:bodyPr>
+          <a:lstStyle/>
+          <a:p>
+            <a:pPr indent="0" marL="0">
+              <a:buNone/>
+            </a:pPr>
+            <a:r>
+              <a:rPr lang="en-US" sz="660" i="1" dirty="0">
+                <a:solidFill>
+                  <a:srgbClr val="626262"/>
+                </a:solidFill>
+                <a:latin typeface="Arial" pitchFamily="34" charset="0"/>
+                <a:ea typeface="Arial" pitchFamily="34" charset="-122"/>
+                <a:cs typeface="Arial" pitchFamily="34" charset="-120"/>
+              </a:rPr>
+              <a:t>Warnings / data-quality notes: {{ww_warnings}}</a:t>
+            </a:r>
+            <a:endParaRPr lang="en-US" sz="660" dirty="0"/>
+          </a:p>
+        </p:txBody>
+      </p:sp>
+      <p:sp>
+        <p:nvSpPr>
+          <p:cNvPr id="54" name="Text 52"/>
+          <p:cNvSpPr/>
+          <p:nvPr/>
+        </p:nvSpPr>
+        <p:spPr>
+          <a:xfrm>
+            <a:off x="9372600" y="7205472"/>
+            <a:ext cx="2286000" cy="118872"/>
+          </a:xfrm>
+          <a:prstGeom prst="rect">
+            <a:avLst/>
+          </a:prstGeom>
+          <a:noFill/>
+          <a:ln/>
+        </p:spPr>
+        <p:txBody>
+          <a:bodyPr wrap="square" lIns="0" tIns="0" rIns="0" bIns="0" rtlCol="0" anchor="t">
+            <a:normAutofit/>
+          </a:bodyPr>
+          <a:lstStyle/>
+          <a:p>
+            <a:pPr algn="r" indent="0" marL="0">
+              <a:buNone/>
+            </a:pPr>
+            <a:r>
+              <a:rPr lang="en-US" sz="580" dirty="0">
+                <a:solidFill>
+                  <a:srgbClr val="626262"/>
+                </a:solidFill>
+                <a:latin typeface="Arial" pitchFamily="34" charset="0"/>
+                <a:ea typeface="Arial" pitchFamily="34" charset="-122"/>
+                <a:cs typeface="Arial" pitchFamily="34" charset="-120"/>
+              </a:rPr>
+              <a:t>{{ww_entity_label}}  •  Slide 1 of 4</a:t>
+            </a:r>
+            <a:endParaRPr lang="en-US" sz="580" dirty="0"/>
+          </a:p>
+        </p:txBody>
+      </p:sp>
+      <p:sp>
+        <p:nvSpPr>
+          <p:cNvPr id="55" name="Shape 53"/>
+          <p:cNvSpPr/>
+          <p:nvPr/>
+        </p:nvSpPr>
+        <p:spPr>
+          <a:xfrm>
+            <a:off x="0" y="8001000"/>
+            <a:ext cx="4572000" cy="411480"/>
+          </a:xfrm>
+          <a:prstGeom prst="rect">
+            <a:avLst/>
+          </a:prstGeom>
+          <a:solidFill>
+            <a:srgbClr val="006578"/>
+          </a:solidFill>
+          <a:ln w="12700">
+            <a:solidFill>
+              <a:srgbClr val="006578">
+                <a:alpha val="0"/>
+              </a:srgbClr>
+            </a:solidFill>
+            <a:prstDash val="solid"/>
+          </a:ln>
+        </p:spPr>
+      </p:sp>
+      <p:sp>
+        <p:nvSpPr>
+          <p:cNvPr id="56" name="Shape 54"/>
+          <p:cNvSpPr/>
+          <p:nvPr/>
+        </p:nvSpPr>
+        <p:spPr>
+          <a:xfrm>
+            <a:off x="4572000" y="8001000"/>
+            <a:ext cx="2194560" cy="411480"/>
           </a:xfrm>
           <a:prstGeom prst="rect">
             <a:avLst/>
@@ -2844,473 +3058,7 @@
       </p:sp>
       <p:sp>
         <p:nvSpPr>
-          <p:cNvPr id="51" name="Text 49"/>
-          <p:cNvSpPr/>
-          <p:nvPr/>
-        </p:nvSpPr>
-        <p:spPr>
-          <a:xfrm>
-            <a:off x="612648" y="4846320"/>
-            <a:ext cx="3657600" cy="155448"/>
-          </a:xfrm>
-          <a:prstGeom prst="rect">
-            <a:avLst/>
-          </a:prstGeom>
-          <a:noFill/>
-          <a:ln/>
-        </p:spPr>
-        <p:txBody>
-          <a:bodyPr wrap="square" lIns="0" tIns="0" rIns="0" bIns="0" rtlCol="0" anchor="t">
-            <a:normAutofit/>
-          </a:bodyPr>
-          <a:lstStyle/>
-          <a:p>
-            <a:pPr indent="0" marL="0">
-              <a:buNone/>
-            </a:pPr>
-            <a:r>
-              <a:rPr lang="en-US" sz="860" b="1" dirty="0">
-                <a:solidFill>
-                  <a:srgbClr val="D9192B"/>
-                </a:solidFill>
-                <a:latin typeface="Arial" pitchFamily="34" charset="0"/>
-                <a:ea typeface="Arial" pitchFamily="34" charset="-122"/>
-                <a:cs typeface="Arial" pitchFamily="34" charset="-120"/>
-              </a:rPr>
-              <a:t>Attrition:</a:t>
-            </a:r>
-            <a:endParaRPr lang="en-US" sz="860" dirty="0"/>
-          </a:p>
-        </p:txBody>
-      </p:sp>
-      <p:sp>
-        <p:nvSpPr>
-          <p:cNvPr id="52" name="Text 50"/>
-          <p:cNvSpPr/>
-          <p:nvPr/>
-        </p:nvSpPr>
-        <p:spPr>
-          <a:xfrm>
-            <a:off x="749808" y="5029200"/>
-            <a:ext cx="10716768" cy="374904"/>
-          </a:xfrm>
-          <a:prstGeom prst="rect">
-            <a:avLst/>
-          </a:prstGeom>
-          <a:noFill/>
-          <a:ln/>
-        </p:spPr>
-        <p:txBody>
-          <a:bodyPr wrap="square" lIns="0" tIns="0" rIns="0" bIns="0" rtlCol="0" anchor="t">
-            <a:normAutofit/>
-          </a:bodyPr>
-          <a:lstStyle/>
-          <a:p>
-            <a:pPr indent="0" marL="0">
-              <a:buNone/>
-            </a:pPr>
-            <a:r>
-              <a:rPr lang="en-US" sz="675" dirty="0">
-                <a:solidFill>
-                  <a:srgbClr val="D9192B"/>
-                </a:solidFill>
-                <a:latin typeface="Arial" pitchFamily="34" charset="0"/>
-                <a:ea typeface="Arial" pitchFamily="34" charset="-122"/>
-                <a:cs typeface="Arial" pitchFamily="34" charset="-120"/>
-              </a:rPr>
-              <a:t>{{ww_attrition_summary}}</a:t>
-            </a:r>
-            <a:endParaRPr lang="en-US" sz="675" dirty="0"/>
-          </a:p>
-          <a:p>
-            <a:pPr indent="0" marL="0">
-              <a:buNone/>
-            </a:pPr>
-            <a:r>
-              <a:rPr lang="en-US" sz="675" dirty="0">
-                <a:solidFill>
-                  <a:srgbClr val="D9192B"/>
-                </a:solidFill>
-                <a:latin typeface="Arial" pitchFamily="34" charset="0"/>
-                <a:ea typeface="Arial" pitchFamily="34" charset="-122"/>
-                <a:cs typeface="Arial" pitchFamily="34" charset="-120"/>
-              </a:rPr>
-              <a:t>{{ww_attrition_detail_or_phase_2_note}}</a:t>
-            </a:r>
-            <a:endParaRPr lang="en-US" sz="675" dirty="0"/>
-          </a:p>
-        </p:txBody>
-      </p:sp>
-      <p:sp>
-        <p:nvSpPr>
-          <p:cNvPr id="53" name="Shape 51"/>
-          <p:cNvSpPr/>
-          <p:nvPr/>
-        </p:nvSpPr>
-        <p:spPr>
-          <a:xfrm>
-            <a:off x="429768" y="5413248"/>
-            <a:ext cx="68580" cy="553212"/>
-          </a:xfrm>
-          <a:prstGeom prst="rect">
-            <a:avLst/>
-          </a:prstGeom>
-          <a:solidFill>
-            <a:srgbClr val="D9192B"/>
-          </a:solidFill>
-          <a:ln w="12700">
-            <a:solidFill>
-              <a:srgbClr val="D9192B">
-                <a:alpha val="0"/>
-              </a:srgbClr>
-            </a:solidFill>
-            <a:prstDash val="solid"/>
-          </a:ln>
-        </p:spPr>
-      </p:sp>
-      <p:sp>
-        <p:nvSpPr>
-          <p:cNvPr id="54" name="Text 52"/>
-          <p:cNvSpPr/>
-          <p:nvPr/>
-        </p:nvSpPr>
-        <p:spPr>
-          <a:xfrm>
-            <a:off x="612648" y="5431536"/>
-            <a:ext cx="3657600" cy="155448"/>
-          </a:xfrm>
-          <a:prstGeom prst="rect">
-            <a:avLst/>
-          </a:prstGeom>
-          <a:noFill/>
-          <a:ln/>
-        </p:spPr>
-        <p:txBody>
-          <a:bodyPr wrap="square" lIns="0" tIns="0" rIns="0" bIns="0" rtlCol="0" anchor="t">
-            <a:normAutofit/>
-          </a:bodyPr>
-          <a:lstStyle/>
-          <a:p>
-            <a:pPr indent="0" marL="0">
-              <a:buNone/>
-            </a:pPr>
-            <a:r>
-              <a:rPr lang="en-US" sz="860" b="1" dirty="0">
-                <a:solidFill>
-                  <a:srgbClr val="D9192B"/>
-                </a:solidFill>
-                <a:latin typeface="Arial" pitchFamily="34" charset="0"/>
-                <a:ea typeface="Arial" pitchFamily="34" charset="-122"/>
-                <a:cs typeface="Arial" pitchFamily="34" charset="-120"/>
-              </a:rPr>
-              <a:t>EBIT:</a:t>
-            </a:r>
-            <a:endParaRPr lang="en-US" sz="860" dirty="0"/>
-          </a:p>
-        </p:txBody>
-      </p:sp>
-      <p:sp>
-        <p:nvSpPr>
-          <p:cNvPr id="55" name="Text 53"/>
-          <p:cNvSpPr/>
-          <p:nvPr/>
-        </p:nvSpPr>
-        <p:spPr>
-          <a:xfrm>
-            <a:off x="749808" y="5614416"/>
-            <a:ext cx="10716768" cy="374904"/>
-          </a:xfrm>
-          <a:prstGeom prst="rect">
-            <a:avLst/>
-          </a:prstGeom>
-          <a:noFill/>
-          <a:ln/>
-        </p:spPr>
-        <p:txBody>
-          <a:bodyPr wrap="square" lIns="0" tIns="0" rIns="0" bIns="0" rtlCol="0" anchor="t">
-            <a:normAutofit/>
-          </a:bodyPr>
-          <a:lstStyle/>
-          <a:p>
-            <a:pPr indent="0" marL="0">
-              <a:buNone/>
-            </a:pPr>
-            <a:r>
-              <a:rPr lang="en-US" sz="675" dirty="0">
-                <a:solidFill>
-                  <a:srgbClr val="D9192B"/>
-                </a:solidFill>
-                <a:latin typeface="Arial" pitchFamily="34" charset="0"/>
-                <a:ea typeface="Arial" pitchFamily="34" charset="-122"/>
-                <a:cs typeface="Arial" pitchFamily="34" charset="-120"/>
-              </a:rPr>
-              <a:t>{{ww_ebit_summary}}</a:t>
-            </a:r>
-            <a:endParaRPr lang="en-US" sz="675" dirty="0"/>
-          </a:p>
-          <a:p>
-            <a:pPr indent="0" marL="0">
-              <a:buNone/>
-            </a:pPr>
-            <a:r>
-              <a:rPr lang="en-US" sz="675" dirty="0">
-                <a:solidFill>
-                  <a:srgbClr val="D9192B"/>
-                </a:solidFill>
-                <a:latin typeface="Arial" pitchFamily="34" charset="0"/>
-                <a:ea typeface="Arial" pitchFamily="34" charset="-122"/>
-                <a:cs typeface="Arial" pitchFamily="34" charset="-120"/>
-              </a:rPr>
-              <a:t>{{ww_ebit_detail_or_phase_2_note}}</a:t>
-            </a:r>
-            <a:endParaRPr lang="en-US" sz="675" dirty="0"/>
-          </a:p>
-        </p:txBody>
-      </p:sp>
-      <p:sp>
-        <p:nvSpPr>
-          <p:cNvPr id="56" name="Shape 54"/>
-          <p:cNvSpPr/>
-          <p:nvPr/>
-        </p:nvSpPr>
-        <p:spPr>
-          <a:xfrm>
-            <a:off x="438912" y="6199632"/>
-            <a:ext cx="11283696" cy="0"/>
-          </a:xfrm>
-          <a:prstGeom prst="line">
-            <a:avLst/>
-          </a:prstGeom>
-          <a:noFill/>
-          <a:ln w="12700">
-            <a:solidFill>
-              <a:srgbClr val="AFAFAF"/>
-            </a:solidFill>
-            <a:prstDash val="solid"/>
-          </a:ln>
-        </p:spPr>
-      </p:sp>
-      <p:sp>
-        <p:nvSpPr>
-          <p:cNvPr id="57" name="Text 55"/>
-          <p:cNvSpPr/>
-          <p:nvPr/>
-        </p:nvSpPr>
-        <p:spPr>
-          <a:xfrm>
-            <a:off x="438912" y="6309360"/>
-            <a:ext cx="1828800" cy="155448"/>
-          </a:xfrm>
-          <a:prstGeom prst="rect">
-            <a:avLst/>
-          </a:prstGeom>
-          <a:noFill/>
-          <a:ln/>
-        </p:spPr>
-        <p:txBody>
-          <a:bodyPr wrap="square" lIns="0" tIns="0" rIns="0" bIns="0" rtlCol="0" anchor="t">
-            <a:normAutofit/>
-          </a:bodyPr>
-          <a:lstStyle/>
-          <a:p>
-            <a:pPr indent="0" marL="0">
-              <a:buNone/>
-            </a:pPr>
-            <a:r>
-              <a:rPr lang="en-US" sz="840" b="1" dirty="0">
-                <a:solidFill>
-                  <a:srgbClr val="8C2465"/>
-                </a:solidFill>
-                <a:latin typeface="Arial" pitchFamily="34" charset="0"/>
-                <a:ea typeface="Arial" pitchFamily="34" charset="-122"/>
-                <a:cs typeface="Arial" pitchFamily="34" charset="-120"/>
-              </a:rPr>
-              <a:t>Source &amp; governance</a:t>
-            </a:r>
-            <a:endParaRPr lang="en-US" sz="840" dirty="0"/>
-          </a:p>
-        </p:txBody>
-      </p:sp>
-      <p:sp>
-        <p:nvSpPr>
-          <p:cNvPr id="58" name="Text 56"/>
-          <p:cNvSpPr/>
-          <p:nvPr/>
-        </p:nvSpPr>
-        <p:spPr>
-          <a:xfrm>
-            <a:off x="438912" y="6519672"/>
-            <a:ext cx="11228832" cy="274320"/>
-          </a:xfrm>
-          <a:prstGeom prst="rect">
-            <a:avLst/>
-          </a:prstGeom>
-          <a:noFill/>
-          <a:ln/>
-        </p:spPr>
-        <p:txBody>
-          <a:bodyPr wrap="square" lIns="0" tIns="0" rIns="0" bIns="0" rtlCol="0" anchor="t">
-            <a:normAutofit/>
-          </a:bodyPr>
-          <a:lstStyle/>
-          <a:p>
-            <a:pPr indent="0" marL="0">
-              <a:buNone/>
-            </a:pPr>
-            <a:r>
-              <a:rPr lang="en-US" sz="670" dirty="0">
-                <a:solidFill>
-                  <a:srgbClr val="626262"/>
-                </a:solidFill>
-                <a:latin typeface="Arial" pitchFamily="34" charset="0"/>
-                <a:ea typeface="Arial" pitchFamily="34" charset="-122"/>
-                <a:cs typeface="Arial" pitchFamily="34" charset="-120"/>
-              </a:rPr>
-              <a:t>{{ww_source_note}}  •  Actuals: {{ww_actual_source_label}}  •  Forecast: {{ww_forecast_source_label}}  •  {{ww_period_label}}</a:t>
-            </a:r>
-            <a:endParaRPr lang="en-US" sz="670" dirty="0"/>
-          </a:p>
-        </p:txBody>
-      </p:sp>
-      <p:sp>
-        <p:nvSpPr>
-          <p:cNvPr id="59" name="Text 57"/>
-          <p:cNvSpPr/>
-          <p:nvPr/>
-        </p:nvSpPr>
-        <p:spPr>
-          <a:xfrm>
-            <a:off x="438912" y="6848856"/>
-            <a:ext cx="11228832" cy="219456"/>
-          </a:xfrm>
-          <a:prstGeom prst="rect">
-            <a:avLst/>
-          </a:prstGeom>
-          <a:noFill/>
-          <a:ln/>
-        </p:spPr>
-        <p:txBody>
-          <a:bodyPr wrap="square" lIns="0" tIns="0" rIns="0" bIns="0" rtlCol="0" anchor="t">
-            <a:normAutofit/>
-          </a:bodyPr>
-          <a:lstStyle/>
-          <a:p>
-            <a:pPr indent="0" marL="0">
-              <a:buNone/>
-            </a:pPr>
-            <a:r>
-              <a:rPr lang="en-US" sz="660" i="1" dirty="0">
-                <a:solidFill>
-                  <a:srgbClr val="626262"/>
-                </a:solidFill>
-                <a:latin typeface="Arial" pitchFamily="34" charset="0"/>
-                <a:ea typeface="Arial" pitchFamily="34" charset="-122"/>
-                <a:cs typeface="Arial" pitchFamily="34" charset="-120"/>
-              </a:rPr>
-              <a:t>Warnings / data-quality notes: {{ww_warnings}}</a:t>
-            </a:r>
-            <a:endParaRPr lang="en-US" sz="660" dirty="0"/>
-          </a:p>
-        </p:txBody>
-      </p:sp>
-      <p:sp>
-        <p:nvSpPr>
-          <p:cNvPr id="60" name="Text 58"/>
-          <p:cNvSpPr/>
-          <p:nvPr/>
-        </p:nvSpPr>
-        <p:spPr>
-          <a:xfrm>
-            <a:off x="9372600" y="7205472"/>
-            <a:ext cx="2286000" cy="118872"/>
-          </a:xfrm>
-          <a:prstGeom prst="rect">
-            <a:avLst/>
-          </a:prstGeom>
-          <a:noFill/>
-          <a:ln/>
-        </p:spPr>
-        <p:txBody>
-          <a:bodyPr wrap="square" lIns="0" tIns="0" rIns="0" bIns="0" rtlCol="0" anchor="t">
-            <a:normAutofit/>
-          </a:bodyPr>
-          <a:lstStyle/>
-          <a:p>
-            <a:pPr algn="r" indent="0" marL="0">
-              <a:buNone/>
-            </a:pPr>
-            <a:r>
-              <a:rPr lang="en-US" sz="580" dirty="0">
-                <a:solidFill>
-                  <a:srgbClr val="626262"/>
-                </a:solidFill>
-                <a:latin typeface="Arial" pitchFamily="34" charset="0"/>
-                <a:ea typeface="Arial" pitchFamily="34" charset="-122"/>
-                <a:cs typeface="Arial" pitchFamily="34" charset="-120"/>
-              </a:rPr>
-              <a:t>{{ww_entity_label}}  •  Slide 1 of 4</a:t>
-            </a:r>
-            <a:endParaRPr lang="en-US" sz="580" dirty="0"/>
-          </a:p>
-        </p:txBody>
-      </p:sp>
-      <p:sp>
-        <p:nvSpPr>
-          <p:cNvPr id="61" name="Shape 59"/>
-          <p:cNvSpPr/>
-          <p:nvPr/>
-        </p:nvSpPr>
-        <p:spPr>
-          <a:xfrm>
-            <a:off x="0" y="8001000"/>
-            <a:ext cx="4572000" cy="411480"/>
-          </a:xfrm>
-          <a:prstGeom prst="rect">
-            <a:avLst/>
-          </a:prstGeom>
-          <a:solidFill>
-            <a:srgbClr val="006578"/>
-          </a:solidFill>
-          <a:ln w="12700">
-            <a:solidFill>
-              <a:srgbClr val="006578">
-                <a:alpha val="0"/>
-              </a:srgbClr>
-            </a:solidFill>
-            <a:prstDash val="solid"/>
-          </a:ln>
-        </p:spPr>
-      </p:sp>
-      <p:sp>
-        <p:nvSpPr>
-          <p:cNvPr id="62" name="Shape 60"/>
-          <p:cNvSpPr/>
-          <p:nvPr/>
-        </p:nvSpPr>
-        <p:spPr>
-          <a:xfrm>
-            <a:off x="4572000" y="8001000"/>
-            <a:ext cx="2194560" cy="411480"/>
-          </a:xfrm>
-          <a:prstGeom prst="rect">
-            <a:avLst/>
-          </a:prstGeom>
-          <a:solidFill>
-            <a:srgbClr val="D9192B"/>
-          </a:solidFill>
-          <a:ln w="12700">
-            <a:solidFill>
-              <a:srgbClr val="D9192B">
-                <a:alpha val="0"/>
-              </a:srgbClr>
-            </a:solidFill>
-            <a:prstDash val="solid"/>
-          </a:ln>
-        </p:spPr>
-      </p:sp>
-      <p:sp>
-        <p:nvSpPr>
-          <p:cNvPr id="63" name="Shape 61"/>
+          <p:cNvPr id="57" name="Shape 55"/>
           <p:cNvSpPr/>
           <p:nvPr/>
         </p:nvSpPr>
@@ -3337,7 +3085,7 @@
       </p:sp>
       <p:sp>
         <p:nvSpPr>
-          <p:cNvPr id="64" name="Shape 62"/>
+          <p:cNvPr id="58" name="Shape 56"/>
           <p:cNvSpPr/>
           <p:nvPr/>
         </p:nvSpPr>
@@ -3364,7 +3112,7 @@
       </p:sp>
       <p:sp>
         <p:nvSpPr>
-          <p:cNvPr id="65" name="Text 63"/>
+          <p:cNvPr id="59" name="Text 57"/>
           <p:cNvSpPr/>
           <p:nvPr/>
         </p:nvSpPr>
@@ -3405,7 +3153,7 @@
       </p:sp>
       <p:sp>
         <p:nvSpPr>
-          <p:cNvPr id="66" name="Text 64"/>
+          <p:cNvPr id="60" name="Text 58"/>
           <p:cNvSpPr/>
           <p:nvPr/>
         </p:nvSpPr>
@@ -4639,7 +4387,7 @@
                 <a:ea typeface="Arial" pitchFamily="34" charset="-122"/>
                 <a:cs typeface="Arial" pitchFamily="34" charset="-120"/>
               </a:rPr>
-              <a:t>Green: governed scope  •  Red: Phase 2 / out of scope</a:t>
+              <a:t>Governed green scope</a:t>
             </a:r>
             <a:endParaRPr lang="en-US" sz="700" dirty="0"/>
           </a:p>
@@ -4654,7 +4402,7 @@
         <p:spPr>
           <a:xfrm>
             <a:off x="429768" y="1938528"/>
-            <a:ext cx="68580" cy="772668"/>
+            <a:ext cx="68580" cy="992124"/>
           </a:xfrm>
           <a:prstGeom prst="rect">
             <a:avLst/>
@@ -4722,7 +4470,7 @@
         <p:spPr>
           <a:xfrm>
             <a:off x="749808" y="2139696"/>
-            <a:ext cx="10716768" cy="594360"/>
+            <a:ext cx="10716768" cy="813816"/>
           </a:xfrm>
           <a:prstGeom prst="rect">
             <a:avLst/>
@@ -4779,8 +4527,8 @@
         </p:nvSpPr>
         <p:spPr>
           <a:xfrm>
-            <a:off x="429768" y="2743200"/>
-            <a:ext cx="68580" cy="662940"/>
+            <a:off x="429768" y="2990088"/>
+            <a:ext cx="68580" cy="937260"/>
           </a:xfrm>
           <a:prstGeom prst="rect">
             <a:avLst/>
@@ -4806,7 +4554,7 @@
         </p:nvSpPr>
         <p:spPr>
           <a:xfrm>
-            <a:off x="612648" y="2761488"/>
+            <a:off x="612648" y="3008376"/>
             <a:ext cx="3657600" cy="155448"/>
           </a:xfrm>
           <a:prstGeom prst="rect">
@@ -4847,8 +4595,8 @@
         </p:nvSpPr>
         <p:spPr>
           <a:xfrm>
-            <a:off x="749808" y="2944368"/>
-            <a:ext cx="10716768" cy="484632"/>
+            <a:off x="749808" y="3191256"/>
+            <a:ext cx="10716768" cy="758952"/>
           </a:xfrm>
           <a:prstGeom prst="rect">
             <a:avLst/>
@@ -4905,8 +4653,8 @@
         </p:nvSpPr>
         <p:spPr>
           <a:xfrm>
-            <a:off x="429768" y="3438144"/>
-            <a:ext cx="68580" cy="662940"/>
+            <a:off x="429768" y="4005072"/>
+            <a:ext cx="68580" cy="937260"/>
           </a:xfrm>
           <a:prstGeom prst="rect">
             <a:avLst/>
@@ -4932,7 +4680,7 @@
         </p:nvSpPr>
         <p:spPr>
           <a:xfrm>
-            <a:off x="612648" y="3456432"/>
+            <a:off x="612648" y="4023360"/>
             <a:ext cx="3657600" cy="155448"/>
           </a:xfrm>
           <a:prstGeom prst="rect">
@@ -4973,8 +4721,8 @@
         </p:nvSpPr>
         <p:spPr>
           <a:xfrm>
-            <a:off x="749808" y="3639312"/>
-            <a:ext cx="10716768" cy="484632"/>
+            <a:off x="749808" y="4206240"/>
+            <a:ext cx="10716768" cy="758952"/>
           </a:xfrm>
           <a:prstGeom prst="rect">
             <a:avLst/>
@@ -5031,8 +4779,8 @@
         </p:nvSpPr>
         <p:spPr>
           <a:xfrm>
-            <a:off x="429768" y="4133088"/>
-            <a:ext cx="68580" cy="662940"/>
+            <a:off x="429768" y="5020056"/>
+            <a:ext cx="68580" cy="937260"/>
           </a:xfrm>
           <a:prstGeom prst="rect">
             <a:avLst/>
@@ -5058,7 +4806,7 @@
         </p:nvSpPr>
         <p:spPr>
           <a:xfrm>
-            <a:off x="612648" y="4151376"/>
+            <a:off x="612648" y="5038344"/>
             <a:ext cx="3657600" cy="155448"/>
           </a:xfrm>
           <a:prstGeom prst="rect">
@@ -5099,8 +4847,8 @@
         </p:nvSpPr>
         <p:spPr>
           <a:xfrm>
-            <a:off x="749808" y="4334256"/>
-            <a:ext cx="10716768" cy="484632"/>
+            <a:off x="749808" y="5221224"/>
+            <a:ext cx="10716768" cy="758952"/>
           </a:xfrm>
           <a:prstGeom prst="rect">
             <a:avLst/>
@@ -5157,8 +4905,222 @@
         </p:nvSpPr>
         <p:spPr>
           <a:xfrm>
-            <a:off x="429768" y="4828032"/>
-            <a:ext cx="68580" cy="553212"/>
+            <a:off x="438912" y="6144768"/>
+            <a:ext cx="11283696" cy="0"/>
+          </a:xfrm>
+          <a:prstGeom prst="line">
+            <a:avLst/>
+          </a:prstGeom>
+          <a:noFill/>
+          <a:ln w="12700">
+            <a:solidFill>
+              <a:srgbClr val="AFAFAF"/>
+            </a:solidFill>
+            <a:prstDash val="solid"/>
+          </a:ln>
+        </p:spPr>
+      </p:sp>
+      <p:sp>
+        <p:nvSpPr>
+          <p:cNvPr id="51" name="Text 49"/>
+          <p:cNvSpPr/>
+          <p:nvPr/>
+        </p:nvSpPr>
+        <p:spPr>
+          <a:xfrm>
+            <a:off x="438912" y="6254496"/>
+            <a:ext cx="1828800" cy="155448"/>
+          </a:xfrm>
+          <a:prstGeom prst="rect">
+            <a:avLst/>
+          </a:prstGeom>
+          <a:noFill/>
+          <a:ln/>
+        </p:spPr>
+        <p:txBody>
+          <a:bodyPr wrap="square" lIns="0" tIns="0" rIns="0" bIns="0" rtlCol="0" anchor="t">
+            <a:normAutofit/>
+          </a:bodyPr>
+          <a:lstStyle/>
+          <a:p>
+            <a:pPr indent="0" marL="0">
+              <a:buNone/>
+            </a:pPr>
+            <a:r>
+              <a:rPr lang="en-US" sz="840" b="1" dirty="0">
+                <a:solidFill>
+                  <a:srgbClr val="8C2465"/>
+                </a:solidFill>
+                <a:latin typeface="Arial" pitchFamily="34" charset="0"/>
+                <a:ea typeface="Arial" pitchFamily="34" charset="-122"/>
+                <a:cs typeface="Arial" pitchFamily="34" charset="-120"/>
+              </a:rPr>
+              <a:t>Source &amp; governance</a:t>
+            </a:r>
+            <a:endParaRPr lang="en-US" sz="840" dirty="0"/>
+          </a:p>
+        </p:txBody>
+      </p:sp>
+      <p:sp>
+        <p:nvSpPr>
+          <p:cNvPr id="52" name="Text 50"/>
+          <p:cNvSpPr/>
+          <p:nvPr/>
+        </p:nvSpPr>
+        <p:spPr>
+          <a:xfrm>
+            <a:off x="438912" y="6464808"/>
+            <a:ext cx="11228832" cy="274320"/>
+          </a:xfrm>
+          <a:prstGeom prst="rect">
+            <a:avLst/>
+          </a:prstGeom>
+          <a:noFill/>
+          <a:ln/>
+        </p:spPr>
+        <p:txBody>
+          <a:bodyPr wrap="square" lIns="0" tIns="0" rIns="0" bIns="0" rtlCol="0" anchor="t">
+            <a:normAutofit/>
+          </a:bodyPr>
+          <a:lstStyle/>
+          <a:p>
+            <a:pPr indent="0" marL="0">
+              <a:buNone/>
+            </a:pPr>
+            <a:r>
+              <a:rPr lang="en-US" sz="670" dirty="0">
+                <a:solidFill>
+                  <a:srgbClr val="626262"/>
+                </a:solidFill>
+                <a:latin typeface="Arial" pitchFamily="34" charset="0"/>
+                <a:ea typeface="Arial" pitchFamily="34" charset="-122"/>
+                <a:cs typeface="Arial" pitchFamily="34" charset="-120"/>
+              </a:rPr>
+              <a:t>{{in_source_note}}  •  Actuals: {{in_actual_source_label}}  •  Forecast: {{in_forecast_source_label}}  •  {{in_period_label}}</a:t>
+            </a:r>
+            <a:endParaRPr lang="en-US" sz="670" dirty="0"/>
+          </a:p>
+        </p:txBody>
+      </p:sp>
+      <p:sp>
+        <p:nvSpPr>
+          <p:cNvPr id="53" name="Text 51"/>
+          <p:cNvSpPr/>
+          <p:nvPr/>
+        </p:nvSpPr>
+        <p:spPr>
+          <a:xfrm>
+            <a:off x="438912" y="6784848"/>
+            <a:ext cx="11228832" cy="219456"/>
+          </a:xfrm>
+          <a:prstGeom prst="rect">
+            <a:avLst/>
+          </a:prstGeom>
+          <a:noFill/>
+          <a:ln/>
+        </p:spPr>
+        <p:txBody>
+          <a:bodyPr wrap="square" lIns="0" tIns="0" rIns="0" bIns="0" rtlCol="0" anchor="t">
+            <a:normAutofit/>
+          </a:bodyPr>
+          <a:lstStyle/>
+          <a:p>
+            <a:pPr indent="0" marL="0">
+              <a:buNone/>
+            </a:pPr>
+            <a:r>
+              <a:rPr lang="en-US" sz="660" i="1" dirty="0">
+                <a:solidFill>
+                  <a:srgbClr val="626262"/>
+                </a:solidFill>
+                <a:latin typeface="Arial" pitchFamily="34" charset="0"/>
+                <a:ea typeface="Arial" pitchFamily="34" charset="-122"/>
+                <a:cs typeface="Arial" pitchFamily="34" charset="-120"/>
+              </a:rPr>
+              <a:t>Warnings / data-quality notes: {{in_warnings}}</a:t>
+            </a:r>
+            <a:endParaRPr lang="en-US" sz="660" dirty="0"/>
+          </a:p>
+        </p:txBody>
+      </p:sp>
+      <p:sp>
+        <p:nvSpPr>
+          <p:cNvPr id="54" name="Text 52"/>
+          <p:cNvSpPr/>
+          <p:nvPr/>
+        </p:nvSpPr>
+        <p:spPr>
+          <a:xfrm>
+            <a:off x="9372600" y="7205472"/>
+            <a:ext cx="2286000" cy="118872"/>
+          </a:xfrm>
+          <a:prstGeom prst="rect">
+            <a:avLst/>
+          </a:prstGeom>
+          <a:noFill/>
+          <a:ln/>
+        </p:spPr>
+        <p:txBody>
+          <a:bodyPr wrap="square" lIns="0" tIns="0" rIns="0" bIns="0" rtlCol="0" anchor="t">
+            <a:normAutofit/>
+          </a:bodyPr>
+          <a:lstStyle/>
+          <a:p>
+            <a:pPr algn="r" indent="0" marL="0">
+              <a:buNone/>
+            </a:pPr>
+            <a:r>
+              <a:rPr lang="en-US" sz="580" dirty="0">
+                <a:solidFill>
+                  <a:srgbClr val="626262"/>
+                </a:solidFill>
+                <a:latin typeface="Arial" pitchFamily="34" charset="0"/>
+                <a:ea typeface="Arial" pitchFamily="34" charset="-122"/>
+                <a:cs typeface="Arial" pitchFamily="34" charset="-120"/>
+              </a:rPr>
+              <a:t>{{in_entity_label}}  •  Slide 2 of 4</a:t>
+            </a:r>
+            <a:endParaRPr lang="en-US" sz="580" dirty="0"/>
+          </a:p>
+        </p:txBody>
+      </p:sp>
+      <p:sp>
+        <p:nvSpPr>
+          <p:cNvPr id="55" name="Shape 53"/>
+          <p:cNvSpPr/>
+          <p:nvPr/>
+        </p:nvSpPr>
+        <p:spPr>
+          <a:xfrm>
+            <a:off x="0" y="8001000"/>
+            <a:ext cx="4572000" cy="411480"/>
+          </a:xfrm>
+          <a:prstGeom prst="rect">
+            <a:avLst/>
+          </a:prstGeom>
+          <a:solidFill>
+            <a:srgbClr val="006578"/>
+          </a:solidFill>
+          <a:ln w="12700">
+            <a:solidFill>
+              <a:srgbClr val="006578">
+                <a:alpha val="0"/>
+              </a:srgbClr>
+            </a:solidFill>
+            <a:prstDash val="solid"/>
+          </a:ln>
+        </p:spPr>
+      </p:sp>
+      <p:sp>
+        <p:nvSpPr>
+          <p:cNvPr id="56" name="Shape 54"/>
+          <p:cNvSpPr/>
+          <p:nvPr/>
+        </p:nvSpPr>
+        <p:spPr>
+          <a:xfrm>
+            <a:off x="4572000" y="8001000"/>
+            <a:ext cx="2194560" cy="411480"/>
           </a:xfrm>
           <a:prstGeom prst="rect">
             <a:avLst/>
@@ -5178,473 +5140,7 @@
       </p:sp>
       <p:sp>
         <p:nvSpPr>
-          <p:cNvPr id="51" name="Text 49"/>
-          <p:cNvSpPr/>
-          <p:nvPr/>
-        </p:nvSpPr>
-        <p:spPr>
-          <a:xfrm>
-            <a:off x="612648" y="4846320"/>
-            <a:ext cx="3657600" cy="155448"/>
-          </a:xfrm>
-          <a:prstGeom prst="rect">
-            <a:avLst/>
-          </a:prstGeom>
-          <a:noFill/>
-          <a:ln/>
-        </p:spPr>
-        <p:txBody>
-          <a:bodyPr wrap="square" lIns="0" tIns="0" rIns="0" bIns="0" rtlCol="0" anchor="t">
-            <a:normAutofit/>
-          </a:bodyPr>
-          <a:lstStyle/>
-          <a:p>
-            <a:pPr indent="0" marL="0">
-              <a:buNone/>
-            </a:pPr>
-            <a:r>
-              <a:rPr lang="en-US" sz="860" b="1" dirty="0">
-                <a:solidFill>
-                  <a:srgbClr val="D9192B"/>
-                </a:solidFill>
-                <a:latin typeface="Arial" pitchFamily="34" charset="0"/>
-                <a:ea typeface="Arial" pitchFamily="34" charset="-122"/>
-                <a:cs typeface="Arial" pitchFamily="34" charset="-120"/>
-              </a:rPr>
-              <a:t>Attrition:</a:t>
-            </a:r>
-            <a:endParaRPr lang="en-US" sz="860" dirty="0"/>
-          </a:p>
-        </p:txBody>
-      </p:sp>
-      <p:sp>
-        <p:nvSpPr>
-          <p:cNvPr id="52" name="Text 50"/>
-          <p:cNvSpPr/>
-          <p:nvPr/>
-        </p:nvSpPr>
-        <p:spPr>
-          <a:xfrm>
-            <a:off x="749808" y="5029200"/>
-            <a:ext cx="10716768" cy="374904"/>
-          </a:xfrm>
-          <a:prstGeom prst="rect">
-            <a:avLst/>
-          </a:prstGeom>
-          <a:noFill/>
-          <a:ln/>
-        </p:spPr>
-        <p:txBody>
-          <a:bodyPr wrap="square" lIns="0" tIns="0" rIns="0" bIns="0" rtlCol="0" anchor="t">
-            <a:normAutofit/>
-          </a:bodyPr>
-          <a:lstStyle/>
-          <a:p>
-            <a:pPr indent="0" marL="0">
-              <a:buNone/>
-            </a:pPr>
-            <a:r>
-              <a:rPr lang="en-US" sz="675" dirty="0">
-                <a:solidFill>
-                  <a:srgbClr val="D9192B"/>
-                </a:solidFill>
-                <a:latin typeface="Arial" pitchFamily="34" charset="0"/>
-                <a:ea typeface="Arial" pitchFamily="34" charset="-122"/>
-                <a:cs typeface="Arial" pitchFamily="34" charset="-120"/>
-              </a:rPr>
-              <a:t>{{in_attrition_summary}}</a:t>
-            </a:r>
-            <a:endParaRPr lang="en-US" sz="675" dirty="0"/>
-          </a:p>
-          <a:p>
-            <a:pPr indent="0" marL="0">
-              <a:buNone/>
-            </a:pPr>
-            <a:r>
-              <a:rPr lang="en-US" sz="675" dirty="0">
-                <a:solidFill>
-                  <a:srgbClr val="D9192B"/>
-                </a:solidFill>
-                <a:latin typeface="Arial" pitchFamily="34" charset="0"/>
-                <a:ea typeface="Arial" pitchFamily="34" charset="-122"/>
-                <a:cs typeface="Arial" pitchFamily="34" charset="-120"/>
-              </a:rPr>
-              <a:t>{{in_attrition_detail_or_phase_2_note}}</a:t>
-            </a:r>
-            <a:endParaRPr lang="en-US" sz="675" dirty="0"/>
-          </a:p>
-        </p:txBody>
-      </p:sp>
-      <p:sp>
-        <p:nvSpPr>
-          <p:cNvPr id="53" name="Shape 51"/>
-          <p:cNvSpPr/>
-          <p:nvPr/>
-        </p:nvSpPr>
-        <p:spPr>
-          <a:xfrm>
-            <a:off x="429768" y="5413248"/>
-            <a:ext cx="68580" cy="553212"/>
-          </a:xfrm>
-          <a:prstGeom prst="rect">
-            <a:avLst/>
-          </a:prstGeom>
-          <a:solidFill>
-            <a:srgbClr val="D9192B"/>
-          </a:solidFill>
-          <a:ln w="12700">
-            <a:solidFill>
-              <a:srgbClr val="D9192B">
-                <a:alpha val="0"/>
-              </a:srgbClr>
-            </a:solidFill>
-            <a:prstDash val="solid"/>
-          </a:ln>
-        </p:spPr>
-      </p:sp>
-      <p:sp>
-        <p:nvSpPr>
-          <p:cNvPr id="54" name="Text 52"/>
-          <p:cNvSpPr/>
-          <p:nvPr/>
-        </p:nvSpPr>
-        <p:spPr>
-          <a:xfrm>
-            <a:off x="612648" y="5431536"/>
-            <a:ext cx="3657600" cy="155448"/>
-          </a:xfrm>
-          <a:prstGeom prst="rect">
-            <a:avLst/>
-          </a:prstGeom>
-          <a:noFill/>
-          <a:ln/>
-        </p:spPr>
-        <p:txBody>
-          <a:bodyPr wrap="square" lIns="0" tIns="0" rIns="0" bIns="0" rtlCol="0" anchor="t">
-            <a:normAutofit/>
-          </a:bodyPr>
-          <a:lstStyle/>
-          <a:p>
-            <a:pPr indent="0" marL="0">
-              <a:buNone/>
-            </a:pPr>
-            <a:r>
-              <a:rPr lang="en-US" sz="860" b="1" dirty="0">
-                <a:solidFill>
-                  <a:srgbClr val="D9192B"/>
-                </a:solidFill>
-                <a:latin typeface="Arial" pitchFamily="34" charset="0"/>
-                <a:ea typeface="Arial" pitchFamily="34" charset="-122"/>
-                <a:cs typeface="Arial" pitchFamily="34" charset="-120"/>
-              </a:rPr>
-              <a:t>EBIT:</a:t>
-            </a:r>
-            <a:endParaRPr lang="en-US" sz="860" dirty="0"/>
-          </a:p>
-        </p:txBody>
-      </p:sp>
-      <p:sp>
-        <p:nvSpPr>
-          <p:cNvPr id="55" name="Text 53"/>
-          <p:cNvSpPr/>
-          <p:nvPr/>
-        </p:nvSpPr>
-        <p:spPr>
-          <a:xfrm>
-            <a:off x="749808" y="5614416"/>
-            <a:ext cx="10716768" cy="374904"/>
-          </a:xfrm>
-          <a:prstGeom prst="rect">
-            <a:avLst/>
-          </a:prstGeom>
-          <a:noFill/>
-          <a:ln/>
-        </p:spPr>
-        <p:txBody>
-          <a:bodyPr wrap="square" lIns="0" tIns="0" rIns="0" bIns="0" rtlCol="0" anchor="t">
-            <a:normAutofit/>
-          </a:bodyPr>
-          <a:lstStyle/>
-          <a:p>
-            <a:pPr indent="0" marL="0">
-              <a:buNone/>
-            </a:pPr>
-            <a:r>
-              <a:rPr lang="en-US" sz="675" dirty="0">
-                <a:solidFill>
-                  <a:srgbClr val="D9192B"/>
-                </a:solidFill>
-                <a:latin typeface="Arial" pitchFamily="34" charset="0"/>
-                <a:ea typeface="Arial" pitchFamily="34" charset="-122"/>
-                <a:cs typeface="Arial" pitchFamily="34" charset="-120"/>
-              </a:rPr>
-              <a:t>{{in_ebit_summary}}</a:t>
-            </a:r>
-            <a:endParaRPr lang="en-US" sz="675" dirty="0"/>
-          </a:p>
-          <a:p>
-            <a:pPr indent="0" marL="0">
-              <a:buNone/>
-            </a:pPr>
-            <a:r>
-              <a:rPr lang="en-US" sz="675" dirty="0">
-                <a:solidFill>
-                  <a:srgbClr val="D9192B"/>
-                </a:solidFill>
-                <a:latin typeface="Arial" pitchFamily="34" charset="0"/>
-                <a:ea typeface="Arial" pitchFamily="34" charset="-122"/>
-                <a:cs typeface="Arial" pitchFamily="34" charset="-120"/>
-              </a:rPr>
-              <a:t>{{in_ebit_detail_or_phase_2_note}}</a:t>
-            </a:r>
-            <a:endParaRPr lang="en-US" sz="675" dirty="0"/>
-          </a:p>
-        </p:txBody>
-      </p:sp>
-      <p:sp>
-        <p:nvSpPr>
-          <p:cNvPr id="56" name="Shape 54"/>
-          <p:cNvSpPr/>
-          <p:nvPr/>
-        </p:nvSpPr>
-        <p:spPr>
-          <a:xfrm>
-            <a:off x="438912" y="6199632"/>
-            <a:ext cx="11283696" cy="0"/>
-          </a:xfrm>
-          <a:prstGeom prst="line">
-            <a:avLst/>
-          </a:prstGeom>
-          <a:noFill/>
-          <a:ln w="12700">
-            <a:solidFill>
-              <a:srgbClr val="AFAFAF"/>
-            </a:solidFill>
-            <a:prstDash val="solid"/>
-          </a:ln>
-        </p:spPr>
-      </p:sp>
-      <p:sp>
-        <p:nvSpPr>
-          <p:cNvPr id="57" name="Text 55"/>
-          <p:cNvSpPr/>
-          <p:nvPr/>
-        </p:nvSpPr>
-        <p:spPr>
-          <a:xfrm>
-            <a:off x="438912" y="6309360"/>
-            <a:ext cx="1828800" cy="155448"/>
-          </a:xfrm>
-          <a:prstGeom prst="rect">
-            <a:avLst/>
-          </a:prstGeom>
-          <a:noFill/>
-          <a:ln/>
-        </p:spPr>
-        <p:txBody>
-          <a:bodyPr wrap="square" lIns="0" tIns="0" rIns="0" bIns="0" rtlCol="0" anchor="t">
-            <a:normAutofit/>
-          </a:bodyPr>
-          <a:lstStyle/>
-          <a:p>
-            <a:pPr indent="0" marL="0">
-              <a:buNone/>
-            </a:pPr>
-            <a:r>
-              <a:rPr lang="en-US" sz="840" b="1" dirty="0">
-                <a:solidFill>
-                  <a:srgbClr val="8C2465"/>
-                </a:solidFill>
-                <a:latin typeface="Arial" pitchFamily="34" charset="0"/>
-                <a:ea typeface="Arial" pitchFamily="34" charset="-122"/>
-                <a:cs typeface="Arial" pitchFamily="34" charset="-120"/>
-              </a:rPr>
-              <a:t>Source &amp; governance</a:t>
-            </a:r>
-            <a:endParaRPr lang="en-US" sz="840" dirty="0"/>
-          </a:p>
-        </p:txBody>
-      </p:sp>
-      <p:sp>
-        <p:nvSpPr>
-          <p:cNvPr id="58" name="Text 56"/>
-          <p:cNvSpPr/>
-          <p:nvPr/>
-        </p:nvSpPr>
-        <p:spPr>
-          <a:xfrm>
-            <a:off x="438912" y="6519672"/>
-            <a:ext cx="11228832" cy="274320"/>
-          </a:xfrm>
-          <a:prstGeom prst="rect">
-            <a:avLst/>
-          </a:prstGeom>
-          <a:noFill/>
-          <a:ln/>
-        </p:spPr>
-        <p:txBody>
-          <a:bodyPr wrap="square" lIns="0" tIns="0" rIns="0" bIns="0" rtlCol="0" anchor="t">
-            <a:normAutofit/>
-          </a:bodyPr>
-          <a:lstStyle/>
-          <a:p>
-            <a:pPr indent="0" marL="0">
-              <a:buNone/>
-            </a:pPr>
-            <a:r>
-              <a:rPr lang="en-US" sz="670" dirty="0">
-                <a:solidFill>
-                  <a:srgbClr val="626262"/>
-                </a:solidFill>
-                <a:latin typeface="Arial" pitchFamily="34" charset="0"/>
-                <a:ea typeface="Arial" pitchFamily="34" charset="-122"/>
-                <a:cs typeface="Arial" pitchFamily="34" charset="-120"/>
-              </a:rPr>
-              <a:t>{{in_source_note}}  •  Actuals: {{in_actual_source_label}}  •  Forecast: {{in_forecast_source_label}}  •  {{in_period_label}}</a:t>
-            </a:r>
-            <a:endParaRPr lang="en-US" sz="670" dirty="0"/>
-          </a:p>
-        </p:txBody>
-      </p:sp>
-      <p:sp>
-        <p:nvSpPr>
-          <p:cNvPr id="59" name="Text 57"/>
-          <p:cNvSpPr/>
-          <p:nvPr/>
-        </p:nvSpPr>
-        <p:spPr>
-          <a:xfrm>
-            <a:off x="438912" y="6848856"/>
-            <a:ext cx="11228832" cy="219456"/>
-          </a:xfrm>
-          <a:prstGeom prst="rect">
-            <a:avLst/>
-          </a:prstGeom>
-          <a:noFill/>
-          <a:ln/>
-        </p:spPr>
-        <p:txBody>
-          <a:bodyPr wrap="square" lIns="0" tIns="0" rIns="0" bIns="0" rtlCol="0" anchor="t">
-            <a:normAutofit/>
-          </a:bodyPr>
-          <a:lstStyle/>
-          <a:p>
-            <a:pPr indent="0" marL="0">
-              <a:buNone/>
-            </a:pPr>
-            <a:r>
-              <a:rPr lang="en-US" sz="660" i="1" dirty="0">
-                <a:solidFill>
-                  <a:srgbClr val="626262"/>
-                </a:solidFill>
-                <a:latin typeface="Arial" pitchFamily="34" charset="0"/>
-                <a:ea typeface="Arial" pitchFamily="34" charset="-122"/>
-                <a:cs typeface="Arial" pitchFamily="34" charset="-120"/>
-              </a:rPr>
-              <a:t>Warnings / data-quality notes: {{in_warnings}}</a:t>
-            </a:r>
-            <a:endParaRPr lang="en-US" sz="660" dirty="0"/>
-          </a:p>
-        </p:txBody>
-      </p:sp>
-      <p:sp>
-        <p:nvSpPr>
-          <p:cNvPr id="60" name="Text 58"/>
-          <p:cNvSpPr/>
-          <p:nvPr/>
-        </p:nvSpPr>
-        <p:spPr>
-          <a:xfrm>
-            <a:off x="9372600" y="7205472"/>
-            <a:ext cx="2286000" cy="118872"/>
-          </a:xfrm>
-          <a:prstGeom prst="rect">
-            <a:avLst/>
-          </a:prstGeom>
-          <a:noFill/>
-          <a:ln/>
-        </p:spPr>
-        <p:txBody>
-          <a:bodyPr wrap="square" lIns="0" tIns="0" rIns="0" bIns="0" rtlCol="0" anchor="t">
-            <a:normAutofit/>
-          </a:bodyPr>
-          <a:lstStyle/>
-          <a:p>
-            <a:pPr algn="r" indent="0" marL="0">
-              <a:buNone/>
-            </a:pPr>
-            <a:r>
-              <a:rPr lang="en-US" sz="580" dirty="0">
-                <a:solidFill>
-                  <a:srgbClr val="626262"/>
-                </a:solidFill>
-                <a:latin typeface="Arial" pitchFamily="34" charset="0"/>
-                <a:ea typeface="Arial" pitchFamily="34" charset="-122"/>
-                <a:cs typeface="Arial" pitchFamily="34" charset="-120"/>
-              </a:rPr>
-              <a:t>{{in_entity_label}}  •  Slide 2 of 4</a:t>
-            </a:r>
-            <a:endParaRPr lang="en-US" sz="580" dirty="0"/>
-          </a:p>
-        </p:txBody>
-      </p:sp>
-      <p:sp>
-        <p:nvSpPr>
-          <p:cNvPr id="61" name="Shape 59"/>
-          <p:cNvSpPr/>
-          <p:nvPr/>
-        </p:nvSpPr>
-        <p:spPr>
-          <a:xfrm>
-            <a:off x="0" y="8001000"/>
-            <a:ext cx="4572000" cy="411480"/>
-          </a:xfrm>
-          <a:prstGeom prst="rect">
-            <a:avLst/>
-          </a:prstGeom>
-          <a:solidFill>
-            <a:srgbClr val="006578"/>
-          </a:solidFill>
-          <a:ln w="12700">
-            <a:solidFill>
-              <a:srgbClr val="006578">
-                <a:alpha val="0"/>
-              </a:srgbClr>
-            </a:solidFill>
-            <a:prstDash val="solid"/>
-          </a:ln>
-        </p:spPr>
-      </p:sp>
-      <p:sp>
-        <p:nvSpPr>
-          <p:cNvPr id="62" name="Shape 60"/>
-          <p:cNvSpPr/>
-          <p:nvPr/>
-        </p:nvSpPr>
-        <p:spPr>
-          <a:xfrm>
-            <a:off x="4572000" y="8001000"/>
-            <a:ext cx="2194560" cy="411480"/>
-          </a:xfrm>
-          <a:prstGeom prst="rect">
-            <a:avLst/>
-          </a:prstGeom>
-          <a:solidFill>
-            <a:srgbClr val="D9192B"/>
-          </a:solidFill>
-          <a:ln w="12700">
-            <a:solidFill>
-              <a:srgbClr val="D9192B">
-                <a:alpha val="0"/>
-              </a:srgbClr>
-            </a:solidFill>
-            <a:prstDash val="solid"/>
-          </a:ln>
-        </p:spPr>
-      </p:sp>
-      <p:sp>
-        <p:nvSpPr>
-          <p:cNvPr id="63" name="Shape 61"/>
+          <p:cNvPr id="57" name="Shape 55"/>
           <p:cNvSpPr/>
           <p:nvPr/>
         </p:nvSpPr>
@@ -5671,7 +5167,7 @@
       </p:sp>
       <p:sp>
         <p:nvSpPr>
-          <p:cNvPr id="64" name="Shape 62"/>
+          <p:cNvPr id="58" name="Shape 56"/>
           <p:cNvSpPr/>
           <p:nvPr/>
         </p:nvSpPr>
@@ -5698,7 +5194,7 @@
       </p:sp>
       <p:sp>
         <p:nvSpPr>
-          <p:cNvPr id="65" name="Text 63"/>
+          <p:cNvPr id="59" name="Text 57"/>
           <p:cNvSpPr/>
           <p:nvPr/>
         </p:nvSpPr>
@@ -5739,7 +5235,7 @@
       </p:sp>
       <p:sp>
         <p:nvSpPr>
-          <p:cNvPr id="66" name="Text 64"/>
+          <p:cNvPr id="60" name="Text 58"/>
           <p:cNvSpPr/>
           <p:nvPr/>
         </p:nvSpPr>
@@ -6973,7 +6469,7 @@
                 <a:ea typeface="Arial" pitchFamily="34" charset="-122"/>
                 <a:cs typeface="Arial" pitchFamily="34" charset="-120"/>
               </a:rPr>
-              <a:t>Green: governed scope  •  Red: Phase 2 / out of scope</a:t>
+              <a:t>Governed green scope</a:t>
             </a:r>
             <a:endParaRPr lang="en-US" sz="700" dirty="0"/>
           </a:p>
@@ -6988,7 +6484,7 @@
         <p:spPr>
           <a:xfrm>
             <a:off x="429768" y="1938528"/>
-            <a:ext cx="68580" cy="772668"/>
+            <a:ext cx="68580" cy="992124"/>
           </a:xfrm>
           <a:prstGeom prst="rect">
             <a:avLst/>
@@ -7056,7 +6552,7 @@
         <p:spPr>
           <a:xfrm>
             <a:off x="749808" y="2139696"/>
-            <a:ext cx="10716768" cy="594360"/>
+            <a:ext cx="10716768" cy="813816"/>
           </a:xfrm>
           <a:prstGeom prst="rect">
             <a:avLst/>
@@ -7113,8 +6609,8 @@
         </p:nvSpPr>
         <p:spPr>
           <a:xfrm>
-            <a:off x="429768" y="2743200"/>
-            <a:ext cx="68580" cy="662940"/>
+            <a:off x="429768" y="2990088"/>
+            <a:ext cx="68580" cy="937260"/>
           </a:xfrm>
           <a:prstGeom prst="rect">
             <a:avLst/>
@@ -7140,7 +6636,7 @@
         </p:nvSpPr>
         <p:spPr>
           <a:xfrm>
-            <a:off x="612648" y="2761488"/>
+            <a:off x="612648" y="3008376"/>
             <a:ext cx="3657600" cy="155448"/>
           </a:xfrm>
           <a:prstGeom prst="rect">
@@ -7181,8 +6677,8 @@
         </p:nvSpPr>
         <p:spPr>
           <a:xfrm>
-            <a:off x="749808" y="2944368"/>
-            <a:ext cx="10716768" cy="484632"/>
+            <a:off x="749808" y="3191256"/>
+            <a:ext cx="10716768" cy="758952"/>
           </a:xfrm>
           <a:prstGeom prst="rect">
             <a:avLst/>
@@ -7239,8 +6735,8 @@
         </p:nvSpPr>
         <p:spPr>
           <a:xfrm>
-            <a:off x="429768" y="3438144"/>
-            <a:ext cx="68580" cy="662940"/>
+            <a:off x="429768" y="4005072"/>
+            <a:ext cx="68580" cy="937260"/>
           </a:xfrm>
           <a:prstGeom prst="rect">
             <a:avLst/>
@@ -7266,7 +6762,7 @@
         </p:nvSpPr>
         <p:spPr>
           <a:xfrm>
-            <a:off x="612648" y="3456432"/>
+            <a:off x="612648" y="4023360"/>
             <a:ext cx="3657600" cy="155448"/>
           </a:xfrm>
           <a:prstGeom prst="rect">
@@ -7307,8 +6803,8 @@
         </p:nvSpPr>
         <p:spPr>
           <a:xfrm>
-            <a:off x="749808" y="3639312"/>
-            <a:ext cx="10716768" cy="484632"/>
+            <a:off x="749808" y="4206240"/>
+            <a:ext cx="10716768" cy="758952"/>
           </a:xfrm>
           <a:prstGeom prst="rect">
             <a:avLst/>
@@ -7365,8 +6861,8 @@
         </p:nvSpPr>
         <p:spPr>
           <a:xfrm>
-            <a:off x="429768" y="4133088"/>
-            <a:ext cx="68580" cy="662940"/>
+            <a:off x="429768" y="5020056"/>
+            <a:ext cx="68580" cy="937260"/>
           </a:xfrm>
           <a:prstGeom prst="rect">
             <a:avLst/>
@@ -7392,7 +6888,7 @@
         </p:nvSpPr>
         <p:spPr>
           <a:xfrm>
-            <a:off x="612648" y="4151376"/>
+            <a:off x="612648" y="5038344"/>
             <a:ext cx="3657600" cy="155448"/>
           </a:xfrm>
           <a:prstGeom prst="rect">
@@ -7433,8 +6929,8 @@
         </p:nvSpPr>
         <p:spPr>
           <a:xfrm>
-            <a:off x="749808" y="4334256"/>
-            <a:ext cx="10716768" cy="484632"/>
+            <a:off x="749808" y="5221224"/>
+            <a:ext cx="10716768" cy="758952"/>
           </a:xfrm>
           <a:prstGeom prst="rect">
             <a:avLst/>
@@ -7491,8 +6987,222 @@
         </p:nvSpPr>
         <p:spPr>
           <a:xfrm>
-            <a:off x="429768" y="4828032"/>
-            <a:ext cx="68580" cy="553212"/>
+            <a:off x="438912" y="6144768"/>
+            <a:ext cx="11283696" cy="0"/>
+          </a:xfrm>
+          <a:prstGeom prst="line">
+            <a:avLst/>
+          </a:prstGeom>
+          <a:noFill/>
+          <a:ln w="12700">
+            <a:solidFill>
+              <a:srgbClr val="AFAFAF"/>
+            </a:solidFill>
+            <a:prstDash val="solid"/>
+          </a:ln>
+        </p:spPr>
+      </p:sp>
+      <p:sp>
+        <p:nvSpPr>
+          <p:cNvPr id="51" name="Text 49"/>
+          <p:cNvSpPr/>
+          <p:nvPr/>
+        </p:nvSpPr>
+        <p:spPr>
+          <a:xfrm>
+            <a:off x="438912" y="6254496"/>
+            <a:ext cx="1828800" cy="155448"/>
+          </a:xfrm>
+          <a:prstGeom prst="rect">
+            <a:avLst/>
+          </a:prstGeom>
+          <a:noFill/>
+          <a:ln/>
+        </p:spPr>
+        <p:txBody>
+          <a:bodyPr wrap="square" lIns="0" tIns="0" rIns="0" bIns="0" rtlCol="0" anchor="t">
+            <a:normAutofit/>
+          </a:bodyPr>
+          <a:lstStyle/>
+          <a:p>
+            <a:pPr indent="0" marL="0">
+              <a:buNone/>
+            </a:pPr>
+            <a:r>
+              <a:rPr lang="en-US" sz="840" b="1" dirty="0">
+                <a:solidFill>
+                  <a:srgbClr val="8C2465"/>
+                </a:solidFill>
+                <a:latin typeface="Arial" pitchFamily="34" charset="0"/>
+                <a:ea typeface="Arial" pitchFamily="34" charset="-122"/>
+                <a:cs typeface="Arial" pitchFamily="34" charset="-120"/>
+              </a:rPr>
+              <a:t>Source &amp; governance</a:t>
+            </a:r>
+            <a:endParaRPr lang="en-US" sz="840" dirty="0"/>
+          </a:p>
+        </p:txBody>
+      </p:sp>
+      <p:sp>
+        <p:nvSpPr>
+          <p:cNvPr id="52" name="Text 50"/>
+          <p:cNvSpPr/>
+          <p:nvPr/>
+        </p:nvSpPr>
+        <p:spPr>
+          <a:xfrm>
+            <a:off x="438912" y="6464808"/>
+            <a:ext cx="11228832" cy="274320"/>
+          </a:xfrm>
+          <a:prstGeom prst="rect">
+            <a:avLst/>
+          </a:prstGeom>
+          <a:noFill/>
+          <a:ln/>
+        </p:spPr>
+        <p:txBody>
+          <a:bodyPr wrap="square" lIns="0" tIns="0" rIns="0" bIns="0" rtlCol="0" anchor="t">
+            <a:normAutofit/>
+          </a:bodyPr>
+          <a:lstStyle/>
+          <a:p>
+            <a:pPr indent="0" marL="0">
+              <a:buNone/>
+            </a:pPr>
+            <a:r>
+              <a:rPr lang="en-US" sz="670" dirty="0">
+                <a:solidFill>
+                  <a:srgbClr val="626262"/>
+                </a:solidFill>
+                <a:latin typeface="Arial" pitchFamily="34" charset="0"/>
+                <a:ea typeface="Arial" pitchFamily="34" charset="-122"/>
+                <a:cs typeface="Arial" pitchFamily="34" charset="-120"/>
+              </a:rPr>
+              <a:t>{{vn_source_note}}  •  Actuals: {{vn_actual_source_label}}  •  Forecast: {{vn_forecast_source_label}}  •  {{vn_period_label}}</a:t>
+            </a:r>
+            <a:endParaRPr lang="en-US" sz="670" dirty="0"/>
+          </a:p>
+        </p:txBody>
+      </p:sp>
+      <p:sp>
+        <p:nvSpPr>
+          <p:cNvPr id="53" name="Text 51"/>
+          <p:cNvSpPr/>
+          <p:nvPr/>
+        </p:nvSpPr>
+        <p:spPr>
+          <a:xfrm>
+            <a:off x="438912" y="6784848"/>
+            <a:ext cx="11228832" cy="219456"/>
+          </a:xfrm>
+          <a:prstGeom prst="rect">
+            <a:avLst/>
+          </a:prstGeom>
+          <a:noFill/>
+          <a:ln/>
+        </p:spPr>
+        <p:txBody>
+          <a:bodyPr wrap="square" lIns="0" tIns="0" rIns="0" bIns="0" rtlCol="0" anchor="t">
+            <a:normAutofit/>
+          </a:bodyPr>
+          <a:lstStyle/>
+          <a:p>
+            <a:pPr indent="0" marL="0">
+              <a:buNone/>
+            </a:pPr>
+            <a:r>
+              <a:rPr lang="en-US" sz="660" i="1" dirty="0">
+                <a:solidFill>
+                  <a:srgbClr val="626262"/>
+                </a:solidFill>
+                <a:latin typeface="Arial" pitchFamily="34" charset="0"/>
+                <a:ea typeface="Arial" pitchFamily="34" charset="-122"/>
+                <a:cs typeface="Arial" pitchFamily="34" charset="-120"/>
+              </a:rPr>
+              <a:t>Warnings / data-quality notes: {{vn_warnings}}</a:t>
+            </a:r>
+            <a:endParaRPr lang="en-US" sz="660" dirty="0"/>
+          </a:p>
+        </p:txBody>
+      </p:sp>
+      <p:sp>
+        <p:nvSpPr>
+          <p:cNvPr id="54" name="Text 52"/>
+          <p:cNvSpPr/>
+          <p:nvPr/>
+        </p:nvSpPr>
+        <p:spPr>
+          <a:xfrm>
+            <a:off x="9372600" y="7205472"/>
+            <a:ext cx="2286000" cy="118872"/>
+          </a:xfrm>
+          <a:prstGeom prst="rect">
+            <a:avLst/>
+          </a:prstGeom>
+          <a:noFill/>
+          <a:ln/>
+        </p:spPr>
+        <p:txBody>
+          <a:bodyPr wrap="square" lIns="0" tIns="0" rIns="0" bIns="0" rtlCol="0" anchor="t">
+            <a:normAutofit/>
+          </a:bodyPr>
+          <a:lstStyle/>
+          <a:p>
+            <a:pPr algn="r" indent="0" marL="0">
+              <a:buNone/>
+            </a:pPr>
+            <a:r>
+              <a:rPr lang="en-US" sz="580" dirty="0">
+                <a:solidFill>
+                  <a:srgbClr val="626262"/>
+                </a:solidFill>
+                <a:latin typeface="Arial" pitchFamily="34" charset="0"/>
+                <a:ea typeface="Arial" pitchFamily="34" charset="-122"/>
+                <a:cs typeface="Arial" pitchFamily="34" charset="-120"/>
+              </a:rPr>
+              <a:t>{{vn_entity_label}}  •  Slide 3 of 4</a:t>
+            </a:r>
+            <a:endParaRPr lang="en-US" sz="580" dirty="0"/>
+          </a:p>
+        </p:txBody>
+      </p:sp>
+      <p:sp>
+        <p:nvSpPr>
+          <p:cNvPr id="55" name="Shape 53"/>
+          <p:cNvSpPr/>
+          <p:nvPr/>
+        </p:nvSpPr>
+        <p:spPr>
+          <a:xfrm>
+            <a:off x="0" y="8001000"/>
+            <a:ext cx="4572000" cy="411480"/>
+          </a:xfrm>
+          <a:prstGeom prst="rect">
+            <a:avLst/>
+          </a:prstGeom>
+          <a:solidFill>
+            <a:srgbClr val="006578"/>
+          </a:solidFill>
+          <a:ln w="12700">
+            <a:solidFill>
+              <a:srgbClr val="006578">
+                <a:alpha val="0"/>
+              </a:srgbClr>
+            </a:solidFill>
+            <a:prstDash val="solid"/>
+          </a:ln>
+        </p:spPr>
+      </p:sp>
+      <p:sp>
+        <p:nvSpPr>
+          <p:cNvPr id="56" name="Shape 54"/>
+          <p:cNvSpPr/>
+          <p:nvPr/>
+        </p:nvSpPr>
+        <p:spPr>
+          <a:xfrm>
+            <a:off x="4572000" y="8001000"/>
+            <a:ext cx="2194560" cy="411480"/>
           </a:xfrm>
           <a:prstGeom prst="rect">
             <a:avLst/>
@@ -7512,473 +7222,7 @@
       </p:sp>
       <p:sp>
         <p:nvSpPr>
-          <p:cNvPr id="51" name="Text 49"/>
-          <p:cNvSpPr/>
-          <p:nvPr/>
-        </p:nvSpPr>
-        <p:spPr>
-          <a:xfrm>
-            <a:off x="612648" y="4846320"/>
-            <a:ext cx="3657600" cy="155448"/>
-          </a:xfrm>
-          <a:prstGeom prst="rect">
-            <a:avLst/>
-          </a:prstGeom>
-          <a:noFill/>
-          <a:ln/>
-        </p:spPr>
-        <p:txBody>
-          <a:bodyPr wrap="square" lIns="0" tIns="0" rIns="0" bIns="0" rtlCol="0" anchor="t">
-            <a:normAutofit/>
-          </a:bodyPr>
-          <a:lstStyle/>
-          <a:p>
-            <a:pPr indent="0" marL="0">
-              <a:buNone/>
-            </a:pPr>
-            <a:r>
-              <a:rPr lang="en-US" sz="860" b="1" dirty="0">
-                <a:solidFill>
-                  <a:srgbClr val="D9192B"/>
-                </a:solidFill>
-                <a:latin typeface="Arial" pitchFamily="34" charset="0"/>
-                <a:ea typeface="Arial" pitchFamily="34" charset="-122"/>
-                <a:cs typeface="Arial" pitchFamily="34" charset="-120"/>
-              </a:rPr>
-              <a:t>Attrition:</a:t>
-            </a:r>
-            <a:endParaRPr lang="en-US" sz="860" dirty="0"/>
-          </a:p>
-        </p:txBody>
-      </p:sp>
-      <p:sp>
-        <p:nvSpPr>
-          <p:cNvPr id="52" name="Text 50"/>
-          <p:cNvSpPr/>
-          <p:nvPr/>
-        </p:nvSpPr>
-        <p:spPr>
-          <a:xfrm>
-            <a:off x="749808" y="5029200"/>
-            <a:ext cx="10716768" cy="374904"/>
-          </a:xfrm>
-          <a:prstGeom prst="rect">
-            <a:avLst/>
-          </a:prstGeom>
-          <a:noFill/>
-          <a:ln/>
-        </p:spPr>
-        <p:txBody>
-          <a:bodyPr wrap="square" lIns="0" tIns="0" rIns="0" bIns="0" rtlCol="0" anchor="t">
-            <a:normAutofit/>
-          </a:bodyPr>
-          <a:lstStyle/>
-          <a:p>
-            <a:pPr indent="0" marL="0">
-              <a:buNone/>
-            </a:pPr>
-            <a:r>
-              <a:rPr lang="en-US" sz="675" dirty="0">
-                <a:solidFill>
-                  <a:srgbClr val="D9192B"/>
-                </a:solidFill>
-                <a:latin typeface="Arial" pitchFamily="34" charset="0"/>
-                <a:ea typeface="Arial" pitchFamily="34" charset="-122"/>
-                <a:cs typeface="Arial" pitchFamily="34" charset="-120"/>
-              </a:rPr>
-              <a:t>{{vn_attrition_summary}}</a:t>
-            </a:r>
-            <a:endParaRPr lang="en-US" sz="675" dirty="0"/>
-          </a:p>
-          <a:p>
-            <a:pPr indent="0" marL="0">
-              <a:buNone/>
-            </a:pPr>
-            <a:r>
-              <a:rPr lang="en-US" sz="675" dirty="0">
-                <a:solidFill>
-                  <a:srgbClr val="D9192B"/>
-                </a:solidFill>
-                <a:latin typeface="Arial" pitchFamily="34" charset="0"/>
-                <a:ea typeface="Arial" pitchFamily="34" charset="-122"/>
-                <a:cs typeface="Arial" pitchFamily="34" charset="-120"/>
-              </a:rPr>
-              <a:t>{{vn_attrition_detail_or_phase_2_note}}</a:t>
-            </a:r>
-            <a:endParaRPr lang="en-US" sz="675" dirty="0"/>
-          </a:p>
-        </p:txBody>
-      </p:sp>
-      <p:sp>
-        <p:nvSpPr>
-          <p:cNvPr id="53" name="Shape 51"/>
-          <p:cNvSpPr/>
-          <p:nvPr/>
-        </p:nvSpPr>
-        <p:spPr>
-          <a:xfrm>
-            <a:off x="429768" y="5413248"/>
-            <a:ext cx="68580" cy="553212"/>
-          </a:xfrm>
-          <a:prstGeom prst="rect">
-            <a:avLst/>
-          </a:prstGeom>
-          <a:solidFill>
-            <a:srgbClr val="D9192B"/>
-          </a:solidFill>
-          <a:ln w="12700">
-            <a:solidFill>
-              <a:srgbClr val="D9192B">
-                <a:alpha val="0"/>
-              </a:srgbClr>
-            </a:solidFill>
-            <a:prstDash val="solid"/>
-          </a:ln>
-        </p:spPr>
-      </p:sp>
-      <p:sp>
-        <p:nvSpPr>
-          <p:cNvPr id="54" name="Text 52"/>
-          <p:cNvSpPr/>
-          <p:nvPr/>
-        </p:nvSpPr>
-        <p:spPr>
-          <a:xfrm>
-            <a:off x="612648" y="5431536"/>
-            <a:ext cx="3657600" cy="155448"/>
-          </a:xfrm>
-          <a:prstGeom prst="rect">
-            <a:avLst/>
-          </a:prstGeom>
-          <a:noFill/>
-          <a:ln/>
-        </p:spPr>
-        <p:txBody>
-          <a:bodyPr wrap="square" lIns="0" tIns="0" rIns="0" bIns="0" rtlCol="0" anchor="t">
-            <a:normAutofit/>
-          </a:bodyPr>
-          <a:lstStyle/>
-          <a:p>
-            <a:pPr indent="0" marL="0">
-              <a:buNone/>
-            </a:pPr>
-            <a:r>
-              <a:rPr lang="en-US" sz="860" b="1" dirty="0">
-                <a:solidFill>
-                  <a:srgbClr val="D9192B"/>
-                </a:solidFill>
-                <a:latin typeface="Arial" pitchFamily="34" charset="0"/>
-                <a:ea typeface="Arial" pitchFamily="34" charset="-122"/>
-                <a:cs typeface="Arial" pitchFamily="34" charset="-120"/>
-              </a:rPr>
-              <a:t>EBIT:</a:t>
-            </a:r>
-            <a:endParaRPr lang="en-US" sz="860" dirty="0"/>
-          </a:p>
-        </p:txBody>
-      </p:sp>
-      <p:sp>
-        <p:nvSpPr>
-          <p:cNvPr id="55" name="Text 53"/>
-          <p:cNvSpPr/>
-          <p:nvPr/>
-        </p:nvSpPr>
-        <p:spPr>
-          <a:xfrm>
-            <a:off x="749808" y="5614416"/>
-            <a:ext cx="10716768" cy="374904"/>
-          </a:xfrm>
-          <a:prstGeom prst="rect">
-            <a:avLst/>
-          </a:prstGeom>
-          <a:noFill/>
-          <a:ln/>
-        </p:spPr>
-        <p:txBody>
-          <a:bodyPr wrap="square" lIns="0" tIns="0" rIns="0" bIns="0" rtlCol="0" anchor="t">
-            <a:normAutofit/>
-          </a:bodyPr>
-          <a:lstStyle/>
-          <a:p>
-            <a:pPr indent="0" marL="0">
-              <a:buNone/>
-            </a:pPr>
-            <a:r>
-              <a:rPr lang="en-US" sz="675" dirty="0">
-                <a:solidFill>
-                  <a:srgbClr val="D9192B"/>
-                </a:solidFill>
-                <a:latin typeface="Arial" pitchFamily="34" charset="0"/>
-                <a:ea typeface="Arial" pitchFamily="34" charset="-122"/>
-                <a:cs typeface="Arial" pitchFamily="34" charset="-120"/>
-              </a:rPr>
-              <a:t>{{vn_ebit_summary}}</a:t>
-            </a:r>
-            <a:endParaRPr lang="en-US" sz="675" dirty="0"/>
-          </a:p>
-          <a:p>
-            <a:pPr indent="0" marL="0">
-              <a:buNone/>
-            </a:pPr>
-            <a:r>
-              <a:rPr lang="en-US" sz="675" dirty="0">
-                <a:solidFill>
-                  <a:srgbClr val="D9192B"/>
-                </a:solidFill>
-                <a:latin typeface="Arial" pitchFamily="34" charset="0"/>
-                <a:ea typeface="Arial" pitchFamily="34" charset="-122"/>
-                <a:cs typeface="Arial" pitchFamily="34" charset="-120"/>
-              </a:rPr>
-              <a:t>{{vn_ebit_detail_or_phase_2_note}}</a:t>
-            </a:r>
-            <a:endParaRPr lang="en-US" sz="675" dirty="0"/>
-          </a:p>
-        </p:txBody>
-      </p:sp>
-      <p:sp>
-        <p:nvSpPr>
-          <p:cNvPr id="56" name="Shape 54"/>
-          <p:cNvSpPr/>
-          <p:nvPr/>
-        </p:nvSpPr>
-        <p:spPr>
-          <a:xfrm>
-            <a:off x="438912" y="6199632"/>
-            <a:ext cx="11283696" cy="0"/>
-          </a:xfrm>
-          <a:prstGeom prst="line">
-            <a:avLst/>
-          </a:prstGeom>
-          <a:noFill/>
-          <a:ln w="12700">
-            <a:solidFill>
-              <a:srgbClr val="AFAFAF"/>
-            </a:solidFill>
-            <a:prstDash val="solid"/>
-          </a:ln>
-        </p:spPr>
-      </p:sp>
-      <p:sp>
-        <p:nvSpPr>
-          <p:cNvPr id="57" name="Text 55"/>
-          <p:cNvSpPr/>
-          <p:nvPr/>
-        </p:nvSpPr>
-        <p:spPr>
-          <a:xfrm>
-            <a:off x="438912" y="6309360"/>
-            <a:ext cx="1828800" cy="155448"/>
-          </a:xfrm>
-          <a:prstGeom prst="rect">
-            <a:avLst/>
-          </a:prstGeom>
-          <a:noFill/>
-          <a:ln/>
-        </p:spPr>
-        <p:txBody>
-          <a:bodyPr wrap="square" lIns="0" tIns="0" rIns="0" bIns="0" rtlCol="0" anchor="t">
-            <a:normAutofit/>
-          </a:bodyPr>
-          <a:lstStyle/>
-          <a:p>
-            <a:pPr indent="0" marL="0">
-              <a:buNone/>
-            </a:pPr>
-            <a:r>
-              <a:rPr lang="en-US" sz="840" b="1" dirty="0">
-                <a:solidFill>
-                  <a:srgbClr val="8C2465"/>
-                </a:solidFill>
-                <a:latin typeface="Arial" pitchFamily="34" charset="0"/>
-                <a:ea typeface="Arial" pitchFamily="34" charset="-122"/>
-                <a:cs typeface="Arial" pitchFamily="34" charset="-120"/>
-              </a:rPr>
-              <a:t>Source &amp; governance</a:t>
-            </a:r>
-            <a:endParaRPr lang="en-US" sz="840" dirty="0"/>
-          </a:p>
-        </p:txBody>
-      </p:sp>
-      <p:sp>
-        <p:nvSpPr>
-          <p:cNvPr id="58" name="Text 56"/>
-          <p:cNvSpPr/>
-          <p:nvPr/>
-        </p:nvSpPr>
-        <p:spPr>
-          <a:xfrm>
-            <a:off x="438912" y="6519672"/>
-            <a:ext cx="11228832" cy="274320"/>
-          </a:xfrm>
-          <a:prstGeom prst="rect">
-            <a:avLst/>
-          </a:prstGeom>
-          <a:noFill/>
-          <a:ln/>
-        </p:spPr>
-        <p:txBody>
-          <a:bodyPr wrap="square" lIns="0" tIns="0" rIns="0" bIns="0" rtlCol="0" anchor="t">
-            <a:normAutofit/>
-          </a:bodyPr>
-          <a:lstStyle/>
-          <a:p>
-            <a:pPr indent="0" marL="0">
-              <a:buNone/>
-            </a:pPr>
-            <a:r>
-              <a:rPr lang="en-US" sz="670" dirty="0">
-                <a:solidFill>
-                  <a:srgbClr val="626262"/>
-                </a:solidFill>
-                <a:latin typeface="Arial" pitchFamily="34" charset="0"/>
-                <a:ea typeface="Arial" pitchFamily="34" charset="-122"/>
-                <a:cs typeface="Arial" pitchFamily="34" charset="-120"/>
-              </a:rPr>
-              <a:t>{{vn_source_note}}  •  Actuals: {{vn_actual_source_label}}  •  Forecast: {{vn_forecast_source_label}}  •  {{vn_period_label}}</a:t>
-            </a:r>
-            <a:endParaRPr lang="en-US" sz="670" dirty="0"/>
-          </a:p>
-        </p:txBody>
-      </p:sp>
-      <p:sp>
-        <p:nvSpPr>
-          <p:cNvPr id="59" name="Text 57"/>
-          <p:cNvSpPr/>
-          <p:nvPr/>
-        </p:nvSpPr>
-        <p:spPr>
-          <a:xfrm>
-            <a:off x="438912" y="6848856"/>
-            <a:ext cx="11228832" cy="219456"/>
-          </a:xfrm>
-          <a:prstGeom prst="rect">
-            <a:avLst/>
-          </a:prstGeom>
-          <a:noFill/>
-          <a:ln/>
-        </p:spPr>
-        <p:txBody>
-          <a:bodyPr wrap="square" lIns="0" tIns="0" rIns="0" bIns="0" rtlCol="0" anchor="t">
-            <a:normAutofit/>
-          </a:bodyPr>
-          <a:lstStyle/>
-          <a:p>
-            <a:pPr indent="0" marL="0">
-              <a:buNone/>
-            </a:pPr>
-            <a:r>
-              <a:rPr lang="en-US" sz="660" i="1" dirty="0">
-                <a:solidFill>
-                  <a:srgbClr val="626262"/>
-                </a:solidFill>
-                <a:latin typeface="Arial" pitchFamily="34" charset="0"/>
-                <a:ea typeface="Arial" pitchFamily="34" charset="-122"/>
-                <a:cs typeface="Arial" pitchFamily="34" charset="-120"/>
-              </a:rPr>
-              <a:t>Warnings / data-quality notes: {{vn_warnings}}</a:t>
-            </a:r>
-            <a:endParaRPr lang="en-US" sz="660" dirty="0"/>
-          </a:p>
-        </p:txBody>
-      </p:sp>
-      <p:sp>
-        <p:nvSpPr>
-          <p:cNvPr id="60" name="Text 58"/>
-          <p:cNvSpPr/>
-          <p:nvPr/>
-        </p:nvSpPr>
-        <p:spPr>
-          <a:xfrm>
-            <a:off x="9372600" y="7205472"/>
-            <a:ext cx="2286000" cy="118872"/>
-          </a:xfrm>
-          <a:prstGeom prst="rect">
-            <a:avLst/>
-          </a:prstGeom>
-          <a:noFill/>
-          <a:ln/>
-        </p:spPr>
-        <p:txBody>
-          <a:bodyPr wrap="square" lIns="0" tIns="0" rIns="0" bIns="0" rtlCol="0" anchor="t">
-            <a:normAutofit/>
-          </a:bodyPr>
-          <a:lstStyle/>
-          <a:p>
-            <a:pPr algn="r" indent="0" marL="0">
-              <a:buNone/>
-            </a:pPr>
-            <a:r>
-              <a:rPr lang="en-US" sz="580" dirty="0">
-                <a:solidFill>
-                  <a:srgbClr val="626262"/>
-                </a:solidFill>
-                <a:latin typeface="Arial" pitchFamily="34" charset="0"/>
-                <a:ea typeface="Arial" pitchFamily="34" charset="-122"/>
-                <a:cs typeface="Arial" pitchFamily="34" charset="-120"/>
-              </a:rPr>
-              <a:t>{{vn_entity_label}}  •  Slide 3 of 4</a:t>
-            </a:r>
-            <a:endParaRPr lang="en-US" sz="580" dirty="0"/>
-          </a:p>
-        </p:txBody>
-      </p:sp>
-      <p:sp>
-        <p:nvSpPr>
-          <p:cNvPr id="61" name="Shape 59"/>
-          <p:cNvSpPr/>
-          <p:nvPr/>
-        </p:nvSpPr>
-        <p:spPr>
-          <a:xfrm>
-            <a:off x="0" y="8001000"/>
-            <a:ext cx="4572000" cy="411480"/>
-          </a:xfrm>
-          <a:prstGeom prst="rect">
-            <a:avLst/>
-          </a:prstGeom>
-          <a:solidFill>
-            <a:srgbClr val="006578"/>
-          </a:solidFill>
-          <a:ln w="12700">
-            <a:solidFill>
-              <a:srgbClr val="006578">
-                <a:alpha val="0"/>
-              </a:srgbClr>
-            </a:solidFill>
-            <a:prstDash val="solid"/>
-          </a:ln>
-        </p:spPr>
-      </p:sp>
-      <p:sp>
-        <p:nvSpPr>
-          <p:cNvPr id="62" name="Shape 60"/>
-          <p:cNvSpPr/>
-          <p:nvPr/>
-        </p:nvSpPr>
-        <p:spPr>
-          <a:xfrm>
-            <a:off x="4572000" y="8001000"/>
-            <a:ext cx="2194560" cy="411480"/>
-          </a:xfrm>
-          <a:prstGeom prst="rect">
-            <a:avLst/>
-          </a:prstGeom>
-          <a:solidFill>
-            <a:srgbClr val="D9192B"/>
-          </a:solidFill>
-          <a:ln w="12700">
-            <a:solidFill>
-              <a:srgbClr val="D9192B">
-                <a:alpha val="0"/>
-              </a:srgbClr>
-            </a:solidFill>
-            <a:prstDash val="solid"/>
-          </a:ln>
-        </p:spPr>
-      </p:sp>
-      <p:sp>
-        <p:nvSpPr>
-          <p:cNvPr id="63" name="Shape 61"/>
+          <p:cNvPr id="57" name="Shape 55"/>
           <p:cNvSpPr/>
           <p:nvPr/>
         </p:nvSpPr>
@@ -8005,7 +7249,7 @@
       </p:sp>
       <p:sp>
         <p:nvSpPr>
-          <p:cNvPr id="64" name="Shape 62"/>
+          <p:cNvPr id="58" name="Shape 56"/>
           <p:cNvSpPr/>
           <p:nvPr/>
         </p:nvSpPr>
@@ -8032,7 +7276,7 @@
       </p:sp>
       <p:sp>
         <p:nvSpPr>
-          <p:cNvPr id="65" name="Text 63"/>
+          <p:cNvPr id="59" name="Text 57"/>
           <p:cNvSpPr/>
           <p:nvPr/>
         </p:nvSpPr>
@@ -8073,7 +7317,7 @@
       </p:sp>
       <p:sp>
         <p:nvSpPr>
-          <p:cNvPr id="66" name="Text 64"/>
+          <p:cNvPr id="60" name="Text 58"/>
           <p:cNvSpPr/>
           <p:nvPr/>
         </p:nvSpPr>
@@ -9307,7 +8551,7 @@
                 <a:ea typeface="Arial" pitchFamily="34" charset="-122"/>
                 <a:cs typeface="Arial" pitchFamily="34" charset="-120"/>
               </a:rPr>
-              <a:t>Green: governed scope  •  Red: Phase 2 / out of scope</a:t>
+              <a:t>Governed green scope</a:t>
             </a:r>
             <a:endParaRPr lang="en-US" sz="700" dirty="0"/>
           </a:p>
@@ -9322,7 +8566,7 @@
         <p:spPr>
           <a:xfrm>
             <a:off x="429768" y="1938528"/>
-            <a:ext cx="68580" cy="772668"/>
+            <a:ext cx="68580" cy="992124"/>
           </a:xfrm>
           <a:prstGeom prst="rect">
             <a:avLst/>
@@ -9390,7 +8634,7 @@
         <p:spPr>
           <a:xfrm>
             <a:off x="749808" y="2139696"/>
-            <a:ext cx="10716768" cy="594360"/>
+            <a:ext cx="10716768" cy="813816"/>
           </a:xfrm>
           <a:prstGeom prst="rect">
             <a:avLst/>
@@ -9447,8 +8691,8 @@
         </p:nvSpPr>
         <p:spPr>
           <a:xfrm>
-            <a:off x="429768" y="2743200"/>
-            <a:ext cx="68580" cy="662940"/>
+            <a:off x="429768" y="2990088"/>
+            <a:ext cx="68580" cy="937260"/>
           </a:xfrm>
           <a:prstGeom prst="rect">
             <a:avLst/>
@@ -9474,7 +8718,7 @@
         </p:nvSpPr>
         <p:spPr>
           <a:xfrm>
-            <a:off x="612648" y="2761488"/>
+            <a:off x="612648" y="3008376"/>
             <a:ext cx="3657600" cy="155448"/>
           </a:xfrm>
           <a:prstGeom prst="rect">
@@ -9515,8 +8759,8 @@
         </p:nvSpPr>
         <p:spPr>
           <a:xfrm>
-            <a:off x="749808" y="2944368"/>
-            <a:ext cx="10716768" cy="484632"/>
+            <a:off x="749808" y="3191256"/>
+            <a:ext cx="10716768" cy="758952"/>
           </a:xfrm>
           <a:prstGeom prst="rect">
             <a:avLst/>
@@ -9573,8 +8817,8 @@
         </p:nvSpPr>
         <p:spPr>
           <a:xfrm>
-            <a:off x="429768" y="3438144"/>
-            <a:ext cx="68580" cy="662940"/>
+            <a:off x="429768" y="4005072"/>
+            <a:ext cx="68580" cy="937260"/>
           </a:xfrm>
           <a:prstGeom prst="rect">
             <a:avLst/>
@@ -9600,7 +8844,7 @@
         </p:nvSpPr>
         <p:spPr>
           <a:xfrm>
-            <a:off x="612648" y="3456432"/>
+            <a:off x="612648" y="4023360"/>
             <a:ext cx="3657600" cy="155448"/>
           </a:xfrm>
           <a:prstGeom prst="rect">
@@ -9641,8 +8885,8 @@
         </p:nvSpPr>
         <p:spPr>
           <a:xfrm>
-            <a:off x="749808" y="3639312"/>
-            <a:ext cx="10716768" cy="484632"/>
+            <a:off x="749808" y="4206240"/>
+            <a:ext cx="10716768" cy="758952"/>
           </a:xfrm>
           <a:prstGeom prst="rect">
             <a:avLst/>
@@ -9699,8 +8943,8 @@
         </p:nvSpPr>
         <p:spPr>
           <a:xfrm>
-            <a:off x="429768" y="4133088"/>
-            <a:ext cx="68580" cy="662940"/>
+            <a:off x="429768" y="5020056"/>
+            <a:ext cx="68580" cy="937260"/>
           </a:xfrm>
           <a:prstGeom prst="rect">
             <a:avLst/>
@@ -9726,7 +8970,7 @@
         </p:nvSpPr>
         <p:spPr>
           <a:xfrm>
-            <a:off x="612648" y="4151376"/>
+            <a:off x="612648" y="5038344"/>
             <a:ext cx="3657600" cy="155448"/>
           </a:xfrm>
           <a:prstGeom prst="rect">
@@ -9767,8 +9011,8 @@
         </p:nvSpPr>
         <p:spPr>
           <a:xfrm>
-            <a:off x="749808" y="4334256"/>
-            <a:ext cx="10716768" cy="484632"/>
+            <a:off x="749808" y="5221224"/>
+            <a:ext cx="10716768" cy="758952"/>
           </a:xfrm>
           <a:prstGeom prst="rect">
             <a:avLst/>
@@ -9825,8 +9069,222 @@
         </p:nvSpPr>
         <p:spPr>
           <a:xfrm>
-            <a:off x="429768" y="4828032"/>
-            <a:ext cx="68580" cy="553212"/>
+            <a:off x="438912" y="6144768"/>
+            <a:ext cx="11283696" cy="0"/>
+          </a:xfrm>
+          <a:prstGeom prst="line">
+            <a:avLst/>
+          </a:prstGeom>
+          <a:noFill/>
+          <a:ln w="12700">
+            <a:solidFill>
+              <a:srgbClr val="AFAFAF"/>
+            </a:solidFill>
+            <a:prstDash val="solid"/>
+          </a:ln>
+        </p:spPr>
+      </p:sp>
+      <p:sp>
+        <p:nvSpPr>
+          <p:cNvPr id="51" name="Text 49"/>
+          <p:cNvSpPr/>
+          <p:nvPr/>
+        </p:nvSpPr>
+        <p:spPr>
+          <a:xfrm>
+            <a:off x="438912" y="6254496"/>
+            <a:ext cx="1828800" cy="155448"/>
+          </a:xfrm>
+          <a:prstGeom prst="rect">
+            <a:avLst/>
+          </a:prstGeom>
+          <a:noFill/>
+          <a:ln/>
+        </p:spPr>
+        <p:txBody>
+          <a:bodyPr wrap="square" lIns="0" tIns="0" rIns="0" bIns="0" rtlCol="0" anchor="t">
+            <a:normAutofit/>
+          </a:bodyPr>
+          <a:lstStyle/>
+          <a:p>
+            <a:pPr indent="0" marL="0">
+              <a:buNone/>
+            </a:pPr>
+            <a:r>
+              <a:rPr lang="en-US" sz="840" b="1" dirty="0">
+                <a:solidFill>
+                  <a:srgbClr val="8C2465"/>
+                </a:solidFill>
+                <a:latin typeface="Arial" pitchFamily="34" charset="0"/>
+                <a:ea typeface="Arial" pitchFamily="34" charset="-122"/>
+                <a:cs typeface="Arial" pitchFamily="34" charset="-120"/>
+              </a:rPr>
+              <a:t>Source &amp; governance</a:t>
+            </a:r>
+            <a:endParaRPr lang="en-US" sz="840" dirty="0"/>
+          </a:p>
+        </p:txBody>
+      </p:sp>
+      <p:sp>
+        <p:nvSpPr>
+          <p:cNvPr id="52" name="Text 50"/>
+          <p:cNvSpPr/>
+          <p:nvPr/>
+        </p:nvSpPr>
+        <p:spPr>
+          <a:xfrm>
+            <a:off x="438912" y="6464808"/>
+            <a:ext cx="11228832" cy="274320"/>
+          </a:xfrm>
+          <a:prstGeom prst="rect">
+            <a:avLst/>
+          </a:prstGeom>
+          <a:noFill/>
+          <a:ln/>
+        </p:spPr>
+        <p:txBody>
+          <a:bodyPr wrap="square" lIns="0" tIns="0" rIns="0" bIns="0" rtlCol="0" anchor="t">
+            <a:normAutofit/>
+          </a:bodyPr>
+          <a:lstStyle/>
+          <a:p>
+            <a:pPr indent="0" marL="0">
+              <a:buNone/>
+            </a:pPr>
+            <a:r>
+              <a:rPr lang="en-US" sz="670" dirty="0">
+                <a:solidFill>
+                  <a:srgbClr val="626262"/>
+                </a:solidFill>
+                <a:latin typeface="Arial" pitchFamily="34" charset="0"/>
+                <a:ea typeface="Arial" pitchFamily="34" charset="-122"/>
+                <a:cs typeface="Arial" pitchFamily="34" charset="-120"/>
+              </a:rPr>
+              <a:t>{{mx_source_note}}  •  Actuals: {{mx_actual_source_label}}  •  Forecast: {{mx_forecast_source_label}}  •  {{mx_period_label}}</a:t>
+            </a:r>
+            <a:endParaRPr lang="en-US" sz="670" dirty="0"/>
+          </a:p>
+        </p:txBody>
+      </p:sp>
+      <p:sp>
+        <p:nvSpPr>
+          <p:cNvPr id="53" name="Text 51"/>
+          <p:cNvSpPr/>
+          <p:nvPr/>
+        </p:nvSpPr>
+        <p:spPr>
+          <a:xfrm>
+            <a:off x="438912" y="6784848"/>
+            <a:ext cx="11228832" cy="219456"/>
+          </a:xfrm>
+          <a:prstGeom prst="rect">
+            <a:avLst/>
+          </a:prstGeom>
+          <a:noFill/>
+          <a:ln/>
+        </p:spPr>
+        <p:txBody>
+          <a:bodyPr wrap="square" lIns="0" tIns="0" rIns="0" bIns="0" rtlCol="0" anchor="t">
+            <a:normAutofit/>
+          </a:bodyPr>
+          <a:lstStyle/>
+          <a:p>
+            <a:pPr indent="0" marL="0">
+              <a:buNone/>
+            </a:pPr>
+            <a:r>
+              <a:rPr lang="en-US" sz="660" i="1" dirty="0">
+                <a:solidFill>
+                  <a:srgbClr val="626262"/>
+                </a:solidFill>
+                <a:latin typeface="Arial" pitchFamily="34" charset="0"/>
+                <a:ea typeface="Arial" pitchFamily="34" charset="-122"/>
+                <a:cs typeface="Arial" pitchFamily="34" charset="-120"/>
+              </a:rPr>
+              <a:t>Warnings / data-quality notes: {{mx_warnings}}</a:t>
+            </a:r>
+            <a:endParaRPr lang="en-US" sz="660" dirty="0"/>
+          </a:p>
+        </p:txBody>
+      </p:sp>
+      <p:sp>
+        <p:nvSpPr>
+          <p:cNvPr id="54" name="Text 52"/>
+          <p:cNvSpPr/>
+          <p:nvPr/>
+        </p:nvSpPr>
+        <p:spPr>
+          <a:xfrm>
+            <a:off x="9372600" y="7205472"/>
+            <a:ext cx="2286000" cy="118872"/>
+          </a:xfrm>
+          <a:prstGeom prst="rect">
+            <a:avLst/>
+          </a:prstGeom>
+          <a:noFill/>
+          <a:ln/>
+        </p:spPr>
+        <p:txBody>
+          <a:bodyPr wrap="square" lIns="0" tIns="0" rIns="0" bIns="0" rtlCol="0" anchor="t">
+            <a:normAutofit/>
+          </a:bodyPr>
+          <a:lstStyle/>
+          <a:p>
+            <a:pPr algn="r" indent="0" marL="0">
+              <a:buNone/>
+            </a:pPr>
+            <a:r>
+              <a:rPr lang="en-US" sz="580" dirty="0">
+                <a:solidFill>
+                  <a:srgbClr val="626262"/>
+                </a:solidFill>
+                <a:latin typeface="Arial" pitchFamily="34" charset="0"/>
+                <a:ea typeface="Arial" pitchFamily="34" charset="-122"/>
+                <a:cs typeface="Arial" pitchFamily="34" charset="-120"/>
+              </a:rPr>
+              <a:t>{{mx_entity_label}}  •  Slide 4 of 4</a:t>
+            </a:r>
+            <a:endParaRPr lang="en-US" sz="580" dirty="0"/>
+          </a:p>
+        </p:txBody>
+      </p:sp>
+      <p:sp>
+        <p:nvSpPr>
+          <p:cNvPr id="55" name="Shape 53"/>
+          <p:cNvSpPr/>
+          <p:nvPr/>
+        </p:nvSpPr>
+        <p:spPr>
+          <a:xfrm>
+            <a:off x="0" y="8001000"/>
+            <a:ext cx="4572000" cy="411480"/>
+          </a:xfrm>
+          <a:prstGeom prst="rect">
+            <a:avLst/>
+          </a:prstGeom>
+          <a:solidFill>
+            <a:srgbClr val="006578"/>
+          </a:solidFill>
+          <a:ln w="12700">
+            <a:solidFill>
+              <a:srgbClr val="006578">
+                <a:alpha val="0"/>
+              </a:srgbClr>
+            </a:solidFill>
+            <a:prstDash val="solid"/>
+          </a:ln>
+        </p:spPr>
+      </p:sp>
+      <p:sp>
+        <p:nvSpPr>
+          <p:cNvPr id="56" name="Shape 54"/>
+          <p:cNvSpPr/>
+          <p:nvPr/>
+        </p:nvSpPr>
+        <p:spPr>
+          <a:xfrm>
+            <a:off x="4572000" y="8001000"/>
+            <a:ext cx="2194560" cy="411480"/>
           </a:xfrm>
           <a:prstGeom prst="rect">
             <a:avLst/>
@@ -9846,473 +9304,7 @@
       </p:sp>
       <p:sp>
         <p:nvSpPr>
-          <p:cNvPr id="51" name="Text 49"/>
-          <p:cNvSpPr/>
-          <p:nvPr/>
-        </p:nvSpPr>
-        <p:spPr>
-          <a:xfrm>
-            <a:off x="612648" y="4846320"/>
-            <a:ext cx="3657600" cy="155448"/>
-          </a:xfrm>
-          <a:prstGeom prst="rect">
-            <a:avLst/>
-          </a:prstGeom>
-          <a:noFill/>
-          <a:ln/>
-        </p:spPr>
-        <p:txBody>
-          <a:bodyPr wrap="square" lIns="0" tIns="0" rIns="0" bIns="0" rtlCol="0" anchor="t">
-            <a:normAutofit/>
-          </a:bodyPr>
-          <a:lstStyle/>
-          <a:p>
-            <a:pPr indent="0" marL="0">
-              <a:buNone/>
-            </a:pPr>
-            <a:r>
-              <a:rPr lang="en-US" sz="860" b="1" dirty="0">
-                <a:solidFill>
-                  <a:srgbClr val="D9192B"/>
-                </a:solidFill>
-                <a:latin typeface="Arial" pitchFamily="34" charset="0"/>
-                <a:ea typeface="Arial" pitchFamily="34" charset="-122"/>
-                <a:cs typeface="Arial" pitchFamily="34" charset="-120"/>
-              </a:rPr>
-              <a:t>Attrition:</a:t>
-            </a:r>
-            <a:endParaRPr lang="en-US" sz="860" dirty="0"/>
-          </a:p>
-        </p:txBody>
-      </p:sp>
-      <p:sp>
-        <p:nvSpPr>
-          <p:cNvPr id="52" name="Text 50"/>
-          <p:cNvSpPr/>
-          <p:nvPr/>
-        </p:nvSpPr>
-        <p:spPr>
-          <a:xfrm>
-            <a:off x="749808" y="5029200"/>
-            <a:ext cx="10716768" cy="374904"/>
-          </a:xfrm>
-          <a:prstGeom prst="rect">
-            <a:avLst/>
-          </a:prstGeom>
-          <a:noFill/>
-          <a:ln/>
-        </p:spPr>
-        <p:txBody>
-          <a:bodyPr wrap="square" lIns="0" tIns="0" rIns="0" bIns="0" rtlCol="0" anchor="t">
-            <a:normAutofit/>
-          </a:bodyPr>
-          <a:lstStyle/>
-          <a:p>
-            <a:pPr indent="0" marL="0">
-              <a:buNone/>
-            </a:pPr>
-            <a:r>
-              <a:rPr lang="en-US" sz="675" dirty="0">
-                <a:solidFill>
-                  <a:srgbClr val="D9192B"/>
-                </a:solidFill>
-                <a:latin typeface="Arial" pitchFamily="34" charset="0"/>
-                <a:ea typeface="Arial" pitchFamily="34" charset="-122"/>
-                <a:cs typeface="Arial" pitchFamily="34" charset="-120"/>
-              </a:rPr>
-              <a:t>{{mx_attrition_summary}}</a:t>
-            </a:r>
-            <a:endParaRPr lang="en-US" sz="675" dirty="0"/>
-          </a:p>
-          <a:p>
-            <a:pPr indent="0" marL="0">
-              <a:buNone/>
-            </a:pPr>
-            <a:r>
-              <a:rPr lang="en-US" sz="675" dirty="0">
-                <a:solidFill>
-                  <a:srgbClr val="D9192B"/>
-                </a:solidFill>
-                <a:latin typeface="Arial" pitchFamily="34" charset="0"/>
-                <a:ea typeface="Arial" pitchFamily="34" charset="-122"/>
-                <a:cs typeface="Arial" pitchFamily="34" charset="-120"/>
-              </a:rPr>
-              <a:t>{{mx_attrition_detail_or_phase_2_note}}</a:t>
-            </a:r>
-            <a:endParaRPr lang="en-US" sz="675" dirty="0"/>
-          </a:p>
-        </p:txBody>
-      </p:sp>
-      <p:sp>
-        <p:nvSpPr>
-          <p:cNvPr id="53" name="Shape 51"/>
-          <p:cNvSpPr/>
-          <p:nvPr/>
-        </p:nvSpPr>
-        <p:spPr>
-          <a:xfrm>
-            <a:off x="429768" y="5413248"/>
-            <a:ext cx="68580" cy="553212"/>
-          </a:xfrm>
-          <a:prstGeom prst="rect">
-            <a:avLst/>
-          </a:prstGeom>
-          <a:solidFill>
-            <a:srgbClr val="D9192B"/>
-          </a:solidFill>
-          <a:ln w="12700">
-            <a:solidFill>
-              <a:srgbClr val="D9192B">
-                <a:alpha val="0"/>
-              </a:srgbClr>
-            </a:solidFill>
-            <a:prstDash val="solid"/>
-          </a:ln>
-        </p:spPr>
-      </p:sp>
-      <p:sp>
-        <p:nvSpPr>
-          <p:cNvPr id="54" name="Text 52"/>
-          <p:cNvSpPr/>
-          <p:nvPr/>
-        </p:nvSpPr>
-        <p:spPr>
-          <a:xfrm>
-            <a:off x="612648" y="5431536"/>
-            <a:ext cx="3657600" cy="155448"/>
-          </a:xfrm>
-          <a:prstGeom prst="rect">
-            <a:avLst/>
-          </a:prstGeom>
-          <a:noFill/>
-          <a:ln/>
-        </p:spPr>
-        <p:txBody>
-          <a:bodyPr wrap="square" lIns="0" tIns="0" rIns="0" bIns="0" rtlCol="0" anchor="t">
-            <a:normAutofit/>
-          </a:bodyPr>
-          <a:lstStyle/>
-          <a:p>
-            <a:pPr indent="0" marL="0">
-              <a:buNone/>
-            </a:pPr>
-            <a:r>
-              <a:rPr lang="en-US" sz="860" b="1" dirty="0">
-                <a:solidFill>
-                  <a:srgbClr val="D9192B"/>
-                </a:solidFill>
-                <a:latin typeface="Arial" pitchFamily="34" charset="0"/>
-                <a:ea typeface="Arial" pitchFamily="34" charset="-122"/>
-                <a:cs typeface="Arial" pitchFamily="34" charset="-120"/>
-              </a:rPr>
-              <a:t>EBIT:</a:t>
-            </a:r>
-            <a:endParaRPr lang="en-US" sz="860" dirty="0"/>
-          </a:p>
-        </p:txBody>
-      </p:sp>
-      <p:sp>
-        <p:nvSpPr>
-          <p:cNvPr id="55" name="Text 53"/>
-          <p:cNvSpPr/>
-          <p:nvPr/>
-        </p:nvSpPr>
-        <p:spPr>
-          <a:xfrm>
-            <a:off x="749808" y="5614416"/>
-            <a:ext cx="10716768" cy="374904"/>
-          </a:xfrm>
-          <a:prstGeom prst="rect">
-            <a:avLst/>
-          </a:prstGeom>
-          <a:noFill/>
-          <a:ln/>
-        </p:spPr>
-        <p:txBody>
-          <a:bodyPr wrap="square" lIns="0" tIns="0" rIns="0" bIns="0" rtlCol="0" anchor="t">
-            <a:normAutofit/>
-          </a:bodyPr>
-          <a:lstStyle/>
-          <a:p>
-            <a:pPr indent="0" marL="0">
-              <a:buNone/>
-            </a:pPr>
-            <a:r>
-              <a:rPr lang="en-US" sz="675" dirty="0">
-                <a:solidFill>
-                  <a:srgbClr val="D9192B"/>
-                </a:solidFill>
-                <a:latin typeface="Arial" pitchFamily="34" charset="0"/>
-                <a:ea typeface="Arial" pitchFamily="34" charset="-122"/>
-                <a:cs typeface="Arial" pitchFamily="34" charset="-120"/>
-              </a:rPr>
-              <a:t>{{mx_ebit_summary}}</a:t>
-            </a:r>
-            <a:endParaRPr lang="en-US" sz="675" dirty="0"/>
-          </a:p>
-          <a:p>
-            <a:pPr indent="0" marL="0">
-              <a:buNone/>
-            </a:pPr>
-            <a:r>
-              <a:rPr lang="en-US" sz="675" dirty="0">
-                <a:solidFill>
-                  <a:srgbClr val="D9192B"/>
-                </a:solidFill>
-                <a:latin typeface="Arial" pitchFamily="34" charset="0"/>
-                <a:ea typeface="Arial" pitchFamily="34" charset="-122"/>
-                <a:cs typeface="Arial" pitchFamily="34" charset="-120"/>
-              </a:rPr>
-              <a:t>{{mx_ebit_detail_or_phase_2_note}}</a:t>
-            </a:r>
-            <a:endParaRPr lang="en-US" sz="675" dirty="0"/>
-          </a:p>
-        </p:txBody>
-      </p:sp>
-      <p:sp>
-        <p:nvSpPr>
-          <p:cNvPr id="56" name="Shape 54"/>
-          <p:cNvSpPr/>
-          <p:nvPr/>
-        </p:nvSpPr>
-        <p:spPr>
-          <a:xfrm>
-            <a:off x="438912" y="6199632"/>
-            <a:ext cx="11283696" cy="0"/>
-          </a:xfrm>
-          <a:prstGeom prst="line">
-            <a:avLst/>
-          </a:prstGeom>
-          <a:noFill/>
-          <a:ln w="12700">
-            <a:solidFill>
-              <a:srgbClr val="AFAFAF"/>
-            </a:solidFill>
-            <a:prstDash val="solid"/>
-          </a:ln>
-        </p:spPr>
-      </p:sp>
-      <p:sp>
-        <p:nvSpPr>
-          <p:cNvPr id="57" name="Text 55"/>
-          <p:cNvSpPr/>
-          <p:nvPr/>
-        </p:nvSpPr>
-        <p:spPr>
-          <a:xfrm>
-            <a:off x="438912" y="6309360"/>
-            <a:ext cx="1828800" cy="155448"/>
-          </a:xfrm>
-          <a:prstGeom prst="rect">
-            <a:avLst/>
-          </a:prstGeom>
-          <a:noFill/>
-          <a:ln/>
-        </p:spPr>
-        <p:txBody>
-          <a:bodyPr wrap="square" lIns="0" tIns="0" rIns="0" bIns="0" rtlCol="0" anchor="t">
-            <a:normAutofit/>
-          </a:bodyPr>
-          <a:lstStyle/>
-          <a:p>
-            <a:pPr indent="0" marL="0">
-              <a:buNone/>
-            </a:pPr>
-            <a:r>
-              <a:rPr lang="en-US" sz="840" b="1" dirty="0">
-                <a:solidFill>
-                  <a:srgbClr val="8C2465"/>
-                </a:solidFill>
-                <a:latin typeface="Arial" pitchFamily="34" charset="0"/>
-                <a:ea typeface="Arial" pitchFamily="34" charset="-122"/>
-                <a:cs typeface="Arial" pitchFamily="34" charset="-120"/>
-              </a:rPr>
-              <a:t>Source &amp; governance</a:t>
-            </a:r>
-            <a:endParaRPr lang="en-US" sz="840" dirty="0"/>
-          </a:p>
-        </p:txBody>
-      </p:sp>
-      <p:sp>
-        <p:nvSpPr>
-          <p:cNvPr id="58" name="Text 56"/>
-          <p:cNvSpPr/>
-          <p:nvPr/>
-        </p:nvSpPr>
-        <p:spPr>
-          <a:xfrm>
-            <a:off x="438912" y="6519672"/>
-            <a:ext cx="11228832" cy="274320"/>
-          </a:xfrm>
-          <a:prstGeom prst="rect">
-            <a:avLst/>
-          </a:prstGeom>
-          <a:noFill/>
-          <a:ln/>
-        </p:spPr>
-        <p:txBody>
-          <a:bodyPr wrap="square" lIns="0" tIns="0" rIns="0" bIns="0" rtlCol="0" anchor="t">
-            <a:normAutofit/>
-          </a:bodyPr>
-          <a:lstStyle/>
-          <a:p>
-            <a:pPr indent="0" marL="0">
-              <a:buNone/>
-            </a:pPr>
-            <a:r>
-              <a:rPr lang="en-US" sz="670" dirty="0">
-                <a:solidFill>
-                  <a:srgbClr val="626262"/>
-                </a:solidFill>
-                <a:latin typeface="Arial" pitchFamily="34" charset="0"/>
-                <a:ea typeface="Arial" pitchFamily="34" charset="-122"/>
-                <a:cs typeface="Arial" pitchFamily="34" charset="-120"/>
-              </a:rPr>
-              <a:t>{{mx_source_note}}  •  Actuals: {{mx_actual_source_label}}  •  Forecast: {{mx_forecast_source_label}}  •  {{mx_period_label}}</a:t>
-            </a:r>
-            <a:endParaRPr lang="en-US" sz="670" dirty="0"/>
-          </a:p>
-        </p:txBody>
-      </p:sp>
-      <p:sp>
-        <p:nvSpPr>
-          <p:cNvPr id="59" name="Text 57"/>
-          <p:cNvSpPr/>
-          <p:nvPr/>
-        </p:nvSpPr>
-        <p:spPr>
-          <a:xfrm>
-            <a:off x="438912" y="6848856"/>
-            <a:ext cx="11228832" cy="219456"/>
-          </a:xfrm>
-          <a:prstGeom prst="rect">
-            <a:avLst/>
-          </a:prstGeom>
-          <a:noFill/>
-          <a:ln/>
-        </p:spPr>
-        <p:txBody>
-          <a:bodyPr wrap="square" lIns="0" tIns="0" rIns="0" bIns="0" rtlCol="0" anchor="t">
-            <a:normAutofit/>
-          </a:bodyPr>
-          <a:lstStyle/>
-          <a:p>
-            <a:pPr indent="0" marL="0">
-              <a:buNone/>
-            </a:pPr>
-            <a:r>
-              <a:rPr lang="en-US" sz="660" i="1" dirty="0">
-                <a:solidFill>
-                  <a:srgbClr val="626262"/>
-                </a:solidFill>
-                <a:latin typeface="Arial" pitchFamily="34" charset="0"/>
-                <a:ea typeface="Arial" pitchFamily="34" charset="-122"/>
-                <a:cs typeface="Arial" pitchFamily="34" charset="-120"/>
-              </a:rPr>
-              <a:t>Warnings / data-quality notes: {{mx_warnings}}</a:t>
-            </a:r>
-            <a:endParaRPr lang="en-US" sz="660" dirty="0"/>
-          </a:p>
-        </p:txBody>
-      </p:sp>
-      <p:sp>
-        <p:nvSpPr>
-          <p:cNvPr id="60" name="Text 58"/>
-          <p:cNvSpPr/>
-          <p:nvPr/>
-        </p:nvSpPr>
-        <p:spPr>
-          <a:xfrm>
-            <a:off x="9372600" y="7205472"/>
-            <a:ext cx="2286000" cy="118872"/>
-          </a:xfrm>
-          <a:prstGeom prst="rect">
-            <a:avLst/>
-          </a:prstGeom>
-          <a:noFill/>
-          <a:ln/>
-        </p:spPr>
-        <p:txBody>
-          <a:bodyPr wrap="square" lIns="0" tIns="0" rIns="0" bIns="0" rtlCol="0" anchor="t">
-            <a:normAutofit/>
-          </a:bodyPr>
-          <a:lstStyle/>
-          <a:p>
-            <a:pPr algn="r" indent="0" marL="0">
-              <a:buNone/>
-            </a:pPr>
-            <a:r>
-              <a:rPr lang="en-US" sz="580" dirty="0">
-                <a:solidFill>
-                  <a:srgbClr val="626262"/>
-                </a:solidFill>
-                <a:latin typeface="Arial" pitchFamily="34" charset="0"/>
-                <a:ea typeface="Arial" pitchFamily="34" charset="-122"/>
-                <a:cs typeface="Arial" pitchFamily="34" charset="-120"/>
-              </a:rPr>
-              <a:t>{{mx_entity_label}}  •  Slide 4 of 4</a:t>
-            </a:r>
-            <a:endParaRPr lang="en-US" sz="580" dirty="0"/>
-          </a:p>
-        </p:txBody>
-      </p:sp>
-      <p:sp>
-        <p:nvSpPr>
-          <p:cNvPr id="61" name="Shape 59"/>
-          <p:cNvSpPr/>
-          <p:nvPr/>
-        </p:nvSpPr>
-        <p:spPr>
-          <a:xfrm>
-            <a:off x="0" y="8001000"/>
-            <a:ext cx="4572000" cy="411480"/>
-          </a:xfrm>
-          <a:prstGeom prst="rect">
-            <a:avLst/>
-          </a:prstGeom>
-          <a:solidFill>
-            <a:srgbClr val="006578"/>
-          </a:solidFill>
-          <a:ln w="12700">
-            <a:solidFill>
-              <a:srgbClr val="006578">
-                <a:alpha val="0"/>
-              </a:srgbClr>
-            </a:solidFill>
-            <a:prstDash val="solid"/>
-          </a:ln>
-        </p:spPr>
-      </p:sp>
-      <p:sp>
-        <p:nvSpPr>
-          <p:cNvPr id="62" name="Shape 60"/>
-          <p:cNvSpPr/>
-          <p:nvPr/>
-        </p:nvSpPr>
-        <p:spPr>
-          <a:xfrm>
-            <a:off x="4572000" y="8001000"/>
-            <a:ext cx="2194560" cy="411480"/>
-          </a:xfrm>
-          <a:prstGeom prst="rect">
-            <a:avLst/>
-          </a:prstGeom>
-          <a:solidFill>
-            <a:srgbClr val="D9192B"/>
-          </a:solidFill>
-          <a:ln w="12700">
-            <a:solidFill>
-              <a:srgbClr val="D9192B">
-                <a:alpha val="0"/>
-              </a:srgbClr>
-            </a:solidFill>
-            <a:prstDash val="solid"/>
-          </a:ln>
-        </p:spPr>
-      </p:sp>
-      <p:sp>
-        <p:nvSpPr>
-          <p:cNvPr id="63" name="Shape 61"/>
+          <p:cNvPr id="57" name="Shape 55"/>
           <p:cNvSpPr/>
           <p:nvPr/>
         </p:nvSpPr>
@@ -10339,7 +9331,7 @@
       </p:sp>
       <p:sp>
         <p:nvSpPr>
-          <p:cNvPr id="64" name="Shape 62"/>
+          <p:cNvPr id="58" name="Shape 56"/>
           <p:cNvSpPr/>
           <p:nvPr/>
         </p:nvSpPr>
@@ -10366,7 +9358,7 @@
       </p:sp>
       <p:sp>
         <p:nvSpPr>
-          <p:cNvPr id="65" name="Text 63"/>
+          <p:cNvPr id="59" name="Text 57"/>
           <p:cNvSpPr/>
           <p:nvPr/>
         </p:nvSpPr>
@@ -10407,7 +9399,7 @@
       </p:sp>
       <p:sp>
         <p:nvSpPr>
-          <p:cNvPr id="66" name="Text 64"/>
+          <p:cNvPr id="60" name="Text 58"/>
           <p:cNvSpPr/>
           <p:nvPr/>
         </p:nvSpPr>

</xml_diff>